<commit_message>
day3: σ ablation 이 --noise-stats 모델도 다루게 한다
stats3 가 나왔다 (val 28.730 / 0.8158, base 28.437 / 0.8103 대비 +0.29 dB).
그런데 ablation 이 estimate_sigma 만 가로채고 있어서, estimate_noise_stats 를 쓰는
noise-stats 모델에서는 아무 일도 하지 않았다. 모델을 보고 어느 쪽을 가로챌지 고른다.

noise-stats 모델에는 항목 둘을 더한다 — 왜도·첨도를 지운 경우와 첨도만 지운 경우.
첨도가 rician 을 가르는 통계이므로, 그것만 지웠을 때 rician 이 무너지면 조건화가
의도대로 일한다는 직접적인 증거가 된다.

Co-Authored-By: Claude Opus 5 (1M context) <noreply@anthropic.com>
</commit_message>
<xml_diff>
--- a/실습5/실습5_day3_발표_v2.pptx
+++ b/실습5/실습5_day3_발표_v2.pptx
@@ -5,26 +5,26 @@
     <p:sldMasterId id="2147483648" r:id="rId1"/>
   </p:sldMasterIdLst>
   <p:sldIdLst>
-    <p:sldId id="256" r:id="rId7"/>
-    <p:sldId id="257" r:id="rId8"/>
-    <p:sldId id="258" r:id="rId9"/>
-    <p:sldId id="259" r:id="rId10"/>
-    <p:sldId id="260" r:id="rId11"/>
-    <p:sldId id="261" r:id="rId12"/>
-    <p:sldId id="262" r:id="rId13"/>
-    <p:sldId id="263" r:id="rId14"/>
-    <p:sldId id="264" r:id="rId15"/>
-    <p:sldId id="265" r:id="rId16"/>
-    <p:sldId id="266" r:id="rId17"/>
-    <p:sldId id="267" r:id="rId18"/>
-    <p:sldId id="268" r:id="rId19"/>
-    <p:sldId id="269" r:id="rId20"/>
-    <p:sldId id="270" r:id="rId21"/>
-    <p:sldId id="271" r:id="rId22"/>
-    <p:sldId id="272" r:id="rId23"/>
-    <p:sldId id="273" r:id="rId24"/>
+    <p:sldId id="256" r:id="rId2"/>
+    <p:sldId id="258" r:id="rId3"/>
+    <p:sldId id="257" r:id="rId4"/>
+    <p:sldId id="259" r:id="rId5"/>
+    <p:sldId id="260" r:id="rId6"/>
+    <p:sldId id="261" r:id="rId7"/>
+    <p:sldId id="262" r:id="rId8"/>
+    <p:sldId id="263" r:id="rId9"/>
+    <p:sldId id="264" r:id="rId10"/>
+    <p:sldId id="265" r:id="rId11"/>
+    <p:sldId id="266" r:id="rId12"/>
+    <p:sldId id="267" r:id="rId13"/>
+    <p:sldId id="268" r:id="rId14"/>
+    <p:sldId id="269" r:id="rId15"/>
+    <p:sldId id="270" r:id="rId16"/>
+    <p:sldId id="271" r:id="rId17"/>
+    <p:sldId id="272" r:id="rId18"/>
+    <p:sldId id="273" r:id="rId19"/>
   </p:sldIdLst>
-  <p:sldSz cx="12191695" cy="6858000" type="screen4x3"/>
+  <p:sldSz cx="12192000" cy="6858000"/>
   <p:notesSz cx="6858000" cy="9144000"/>
   <p:defaultTextStyle>
     <a:defPPr>
@@ -121,6 +121,22 @@
       </a:defRPr>
     </a:lvl9pPr>
   </p:defaultTextStyle>
+  <p:extLst>
+    <p:ext uri="{EFAFB233-063F-42B5-8137-9DF3F51BA10A}">
+      <p15:sldGuideLst xmlns:p15="http://schemas.microsoft.com/office/powerpoint/2012/main">
+        <p15:guide id="1" orient="horz" pos="2160">
+          <p15:clr>
+            <a:srgbClr val="A4A3A4"/>
+          </p15:clr>
+        </p15:guide>
+        <p15:guide id="2" pos="2880">
+          <p15:clr>
+            <a:srgbClr val="A4A3A4"/>
+          </p15:clr>
+        </p15:guide>
+      </p15:sldGuideLst>
+    </p:ext>
+  </p:extLst>
 </p:presentation>
 </file>
 
@@ -305,7 +321,7 @@
           <a:p>
             <a:fld id="{5BCAD085-E8A6-8845-BD4E-CB4CCA059FC4}" type="datetimeFigureOut">
               <a:rPr lang="en-US" smtClean="0"/>
-              <a:t>1/27/13</a:t>
+              <a:t>9/2/2026</a:t>
             </a:fld>
             <a:endParaRPr lang="en-US"/>
           </a:p>
@@ -475,7 +491,7 @@
           <a:p>
             <a:fld id="{5BCAD085-E8A6-8845-BD4E-CB4CCA059FC4}" type="datetimeFigureOut">
               <a:rPr lang="en-US" smtClean="0"/>
-              <a:t>1/27/13</a:t>
+              <a:t>9/2/2026</a:t>
             </a:fld>
             <a:endParaRPr lang="en-US"/>
           </a:p>
@@ -655,7 +671,7 @@
           <a:p>
             <a:fld id="{5BCAD085-E8A6-8845-BD4E-CB4CCA059FC4}" type="datetimeFigureOut">
               <a:rPr lang="en-US" smtClean="0"/>
-              <a:t>1/27/13</a:t>
+              <a:t>9/2/2026</a:t>
             </a:fld>
             <a:endParaRPr lang="en-US"/>
           </a:p>
@@ -825,7 +841,7 @@
           <a:p>
             <a:fld id="{5BCAD085-E8A6-8845-BD4E-CB4CCA059FC4}" type="datetimeFigureOut">
               <a:rPr lang="en-US" smtClean="0"/>
-              <a:t>1/27/13</a:t>
+              <a:t>9/2/2026</a:t>
             </a:fld>
             <a:endParaRPr lang="en-US"/>
           </a:p>
@@ -1071,7 +1087,7 @@
           <a:p>
             <a:fld id="{5BCAD085-E8A6-8845-BD4E-CB4CCA059FC4}" type="datetimeFigureOut">
               <a:rPr lang="en-US" smtClean="0"/>
-              <a:t>1/27/13</a:t>
+              <a:t>9/2/2026</a:t>
             </a:fld>
             <a:endParaRPr lang="en-US"/>
           </a:p>
@@ -1359,7 +1375,7 @@
           <a:p>
             <a:fld id="{5BCAD085-E8A6-8845-BD4E-CB4CCA059FC4}" type="datetimeFigureOut">
               <a:rPr lang="en-US" smtClean="0"/>
-              <a:t>1/27/13</a:t>
+              <a:t>9/2/2026</a:t>
             </a:fld>
             <a:endParaRPr lang="en-US"/>
           </a:p>
@@ -1781,7 +1797,7 @@
           <a:p>
             <a:fld id="{5BCAD085-E8A6-8845-BD4E-CB4CCA059FC4}" type="datetimeFigureOut">
               <a:rPr lang="en-US" smtClean="0"/>
-              <a:t>1/27/13</a:t>
+              <a:t>9/2/2026</a:t>
             </a:fld>
             <a:endParaRPr lang="en-US"/>
           </a:p>
@@ -1899,7 +1915,7 @@
           <a:p>
             <a:fld id="{5BCAD085-E8A6-8845-BD4E-CB4CCA059FC4}" type="datetimeFigureOut">
               <a:rPr lang="en-US" smtClean="0"/>
-              <a:t>1/27/13</a:t>
+              <a:t>9/2/2026</a:t>
             </a:fld>
             <a:endParaRPr lang="en-US"/>
           </a:p>
@@ -1994,7 +2010,7 @@
           <a:p>
             <a:fld id="{5BCAD085-E8A6-8845-BD4E-CB4CCA059FC4}" type="datetimeFigureOut">
               <a:rPr lang="en-US" smtClean="0"/>
-              <a:t>1/27/13</a:t>
+              <a:t>9/2/2026</a:t>
             </a:fld>
             <a:endParaRPr lang="en-US"/>
           </a:p>
@@ -2271,7 +2287,7 @@
           <a:p>
             <a:fld id="{5BCAD085-E8A6-8845-BD4E-CB4CCA059FC4}" type="datetimeFigureOut">
               <a:rPr lang="en-US" smtClean="0"/>
-              <a:t>1/27/13</a:t>
+              <a:t>9/2/2026</a:t>
             </a:fld>
             <a:endParaRPr lang="en-US"/>
           </a:p>
@@ -2524,7 +2540,7 @@
           <a:p>
             <a:fld id="{5BCAD085-E8A6-8845-BD4E-CB4CCA059FC4}" type="datetimeFigureOut">
               <a:rPr lang="en-US" smtClean="0"/>
-              <a:t>1/27/13</a:t>
+              <a:t>9/2/2026</a:t>
             </a:fld>
             <a:endParaRPr lang="en-US"/>
           </a:p>
@@ -2737,7 +2753,7 @@
           <a:p>
             <a:fld id="{5BCAD085-E8A6-8845-BD4E-CB4CCA059FC4}" type="datetimeFigureOut">
               <a:rPr lang="en-US" smtClean="0"/>
-              <a:t>1/27/13</a:t>
+              <a:t>9/2/2026</a:t>
             </a:fld>
             <a:endParaRPr lang="en-US"/>
           </a:p>
@@ -3096,7 +3112,7 @@
 </file>
 
 <file path=ppt/slides/slide1.xml><?xml version="1.0" encoding="utf-8"?>
-<p:sld xmlns:a="http://schemas.openxmlformats.org/drawingml/2006/main" xmlns:p="http://schemas.openxmlformats.org/presentationml/2006/main" xmlns:r="http://schemas.openxmlformats.org/officeDocument/2006/relationships">
+<p:sld xmlns:a="http://schemas.openxmlformats.org/drawingml/2006/main" xmlns:r="http://schemas.openxmlformats.org/officeDocument/2006/relationships" xmlns:p="http://schemas.openxmlformats.org/presentationml/2006/main">
   <p:cSld>
     <p:bg>
       <p:bgPr>
@@ -3112,7 +3128,14 @@
         <p:cNvGrpSpPr/>
         <p:nvPr/>
       </p:nvGrpSpPr>
-      <p:grpSpPr/>
+      <p:grpSpPr>
+        <a:xfrm>
+          <a:off x="0" y="0"/>
+          <a:ext cx="0" cy="0"/>
+          <a:chOff x="0" y="0"/>
+          <a:chExt cx="0" cy="0"/>
+        </a:xfrm>
+      </p:grpSpPr>
       <p:sp>
         <p:nvSpPr>
           <p:cNvPr id="2" name="Rectangle 1"/>
@@ -3154,6 +3177,7 @@
           <a:lstStyle/>
           <a:p>
             <a:pPr algn="ctr"/>
+            <a:endParaRPr/>
           </a:p>
         </p:txBody>
       </p:sp>
@@ -3358,6 +3382,7 @@
           <a:lstStyle/>
           <a:p>
             <a:pPr algn="ctr"/>
+            <a:endParaRPr/>
           </a:p>
         </p:txBody>
       </p:sp>
@@ -3484,6 +3509,7 @@
           <a:lstStyle/>
           <a:p>
             <a:pPr algn="ctr"/>
+            <a:endParaRPr/>
           </a:p>
         </p:txBody>
       </p:sp>
@@ -3574,7 +3600,7 @@
 </file>
 
 <file path=ppt/slides/slide10.xml><?xml version="1.0" encoding="utf-8"?>
-<p:sld xmlns:a="http://schemas.openxmlformats.org/drawingml/2006/main" xmlns:p="http://schemas.openxmlformats.org/presentationml/2006/main" xmlns:r="http://schemas.openxmlformats.org/officeDocument/2006/relationships">
+<p:sld xmlns:a="http://schemas.openxmlformats.org/drawingml/2006/main" xmlns:r="http://schemas.openxmlformats.org/officeDocument/2006/relationships" xmlns:p="http://schemas.openxmlformats.org/presentationml/2006/main">
   <p:cSld>
     <p:bg>
       <p:bgPr>
@@ -3590,7 +3616,14 @@
         <p:cNvGrpSpPr/>
         <p:nvPr/>
       </p:nvGrpSpPr>
-      <p:grpSpPr/>
+      <p:grpSpPr>
+        <a:xfrm>
+          <a:off x="0" y="0"/>
+          <a:ext cx="0" cy="0"/>
+          <a:chOff x="0" y="0"/>
+          <a:chExt cx="0" cy="0"/>
+        </a:xfrm>
+      </p:grpSpPr>
       <p:sp>
         <p:nvSpPr>
           <p:cNvPr id="2" name="TextBox 1"/>
@@ -3749,6 +3782,7 @@
           <a:lstStyle/>
           <a:p>
             <a:pPr algn="ctr"/>
+            <a:endParaRPr/>
           </a:p>
         </p:txBody>
       </p:sp>
@@ -3824,7 +3858,7 @@
 </file>
 
 <file path=ppt/slides/slide11.xml><?xml version="1.0" encoding="utf-8"?>
-<p:sld xmlns:a="http://schemas.openxmlformats.org/drawingml/2006/main" xmlns:p="http://schemas.openxmlformats.org/presentationml/2006/main" xmlns:r="http://schemas.openxmlformats.org/officeDocument/2006/relationships">
+<p:sld xmlns:a="http://schemas.openxmlformats.org/drawingml/2006/main" xmlns:r="http://schemas.openxmlformats.org/officeDocument/2006/relationships" xmlns:p="http://schemas.openxmlformats.org/presentationml/2006/main">
   <p:cSld>
     <p:bg>
       <p:bgPr>
@@ -3840,7 +3874,14 @@
         <p:cNvGrpSpPr/>
         <p:nvPr/>
       </p:nvGrpSpPr>
-      <p:grpSpPr/>
+      <p:grpSpPr>
+        <a:xfrm>
+          <a:off x="0" y="0"/>
+          <a:ext cx="0" cy="0"/>
+          <a:chOff x="0" y="0"/>
+          <a:chExt cx="0" cy="0"/>
+        </a:xfrm>
+      </p:grpSpPr>
       <p:sp>
         <p:nvSpPr>
           <p:cNvPr id="2" name="TextBox 1"/>
@@ -3960,6 +4001,7 @@
           <a:lstStyle/>
           <a:p>
             <a:pPr algn="ctr"/>
+            <a:endParaRPr/>
           </a:p>
         </p:txBody>
       </p:sp>
@@ -4035,7 +4077,7 @@
 </file>
 
 <file path=ppt/slides/slide12.xml><?xml version="1.0" encoding="utf-8"?>
-<p:sld xmlns:a="http://schemas.openxmlformats.org/drawingml/2006/main" xmlns:p="http://schemas.openxmlformats.org/presentationml/2006/main" xmlns:r="http://schemas.openxmlformats.org/officeDocument/2006/relationships">
+<p:sld xmlns:a="http://schemas.openxmlformats.org/drawingml/2006/main" xmlns:r="http://schemas.openxmlformats.org/officeDocument/2006/relationships" xmlns:p="http://schemas.openxmlformats.org/presentationml/2006/main">
   <p:cSld>
     <p:bg>
       <p:bgPr>
@@ -4051,7 +4093,14 @@
         <p:cNvGrpSpPr/>
         <p:nvPr/>
       </p:nvGrpSpPr>
-      <p:grpSpPr/>
+      <p:grpSpPr>
+        <a:xfrm>
+          <a:off x="0" y="0"/>
+          <a:ext cx="0" cy="0"/>
+          <a:chOff x="0" y="0"/>
+          <a:chExt cx="0" cy="0"/>
+        </a:xfrm>
+      </p:grpSpPr>
       <p:sp>
         <p:nvSpPr>
           <p:cNvPr id="2" name="TextBox 1"/>
@@ -4210,6 +4259,7 @@
           <a:lstStyle/>
           <a:p>
             <a:pPr algn="ctr"/>
+            <a:endParaRPr/>
           </a:p>
         </p:txBody>
       </p:sp>
@@ -4245,7 +4295,7 @@
         </p:nvSpPr>
         <p:spPr>
           <a:xfrm>
-            <a:off x="822960" y="4114800"/>
+            <a:off x="914400" y="4821336"/>
             <a:ext cx="10515600" cy="274320"/>
           </a:xfrm>
           <a:prstGeom prst="rect">
@@ -4265,14 +4315,56 @@
               </a:lnSpc>
             </a:pPr>
             <a:r>
-              <a:rPr sz="1250" b="1">
+              <a:rPr sz="1250" b="1" dirty="0" err="1">
                 <a:solidFill>
                   <a:srgbClr val="131A19"/>
                 </a:solidFill>
                 <a:latin typeface="맑은 고딕"/>
               </a:rPr>
-              <a:t>Rician 이 가장 약하다</a:t>
-            </a:r>
+              <a:t>Rician</a:t>
+            </a:r>
+            <a:r>
+              <a:rPr sz="1250" b="1" dirty="0">
+                <a:solidFill>
+                  <a:srgbClr val="131A19"/>
+                </a:solidFill>
+                <a:latin typeface="맑은 고딕"/>
+              </a:rPr>
+              <a:t> 이 </a:t>
+            </a:r>
+            <a:r>
+              <a:rPr sz="1250" b="1" dirty="0" err="1">
+                <a:solidFill>
+                  <a:srgbClr val="131A19"/>
+                </a:solidFill>
+                <a:latin typeface="맑은 고딕"/>
+              </a:rPr>
+              <a:t>가장</a:t>
+            </a:r>
+            <a:r>
+              <a:rPr sz="1250" b="1" dirty="0">
+                <a:solidFill>
+                  <a:srgbClr val="131A19"/>
+                </a:solidFill>
+                <a:latin typeface="맑은 고딕"/>
+              </a:rPr>
+              <a:t> </a:t>
+            </a:r>
+            <a:r>
+              <a:rPr sz="1250" b="1" dirty="0" err="1">
+                <a:solidFill>
+                  <a:srgbClr val="131A19"/>
+                </a:solidFill>
+                <a:latin typeface="맑은 고딕"/>
+              </a:rPr>
+              <a:t>약하다</a:t>
+            </a:r>
+            <a:endParaRPr sz="1250" b="1" dirty="0">
+              <a:solidFill>
+                <a:srgbClr val="131A19"/>
+              </a:solidFill>
+              <a:latin typeface="맑은 고딕"/>
+            </a:endParaRPr>
           </a:p>
         </p:txBody>
       </p:sp>
@@ -4284,7 +4376,7 @@
         </p:nvSpPr>
         <p:spPr>
           <a:xfrm>
-            <a:off x="822960" y="4370832"/>
+            <a:off x="914400" y="5077368"/>
             <a:ext cx="10515600" cy="274320"/>
           </a:xfrm>
           <a:prstGeom prst="rect">
@@ -4323,7 +4415,7 @@
         </p:nvSpPr>
         <p:spPr>
           <a:xfrm>
-            <a:off x="822960" y="4718304"/>
+            <a:off x="914400" y="5424840"/>
             <a:ext cx="10515600" cy="274320"/>
           </a:xfrm>
           <a:prstGeom prst="rect">
@@ -4362,7 +4454,7 @@
         </p:nvSpPr>
         <p:spPr>
           <a:xfrm>
-            <a:off x="822960" y="4974336"/>
+            <a:off x="914400" y="5680872"/>
             <a:ext cx="10515600" cy="274320"/>
           </a:xfrm>
           <a:prstGeom prst="rect">
@@ -4401,7 +4493,7 @@
         </p:nvSpPr>
         <p:spPr>
           <a:xfrm>
-            <a:off x="822960" y="5321808"/>
+            <a:off x="914400" y="6028344"/>
             <a:ext cx="10515600" cy="274320"/>
           </a:xfrm>
           <a:prstGeom prst="rect">
@@ -4440,7 +4532,7 @@
         </p:nvSpPr>
         <p:spPr>
           <a:xfrm>
-            <a:off x="822960" y="5577840"/>
+            <a:off x="914400" y="6284376"/>
             <a:ext cx="10515600" cy="274320"/>
           </a:xfrm>
           <a:prstGeom prst="rect">
@@ -4480,7 +4572,7 @@
 </file>
 
 <file path=ppt/slides/slide13.xml><?xml version="1.0" encoding="utf-8"?>
-<p:sld xmlns:a="http://schemas.openxmlformats.org/drawingml/2006/main" xmlns:p="http://schemas.openxmlformats.org/presentationml/2006/main" xmlns:r="http://schemas.openxmlformats.org/officeDocument/2006/relationships">
+<p:sld xmlns:a="http://schemas.openxmlformats.org/drawingml/2006/main" xmlns:r="http://schemas.openxmlformats.org/officeDocument/2006/relationships" xmlns:p="http://schemas.openxmlformats.org/presentationml/2006/main">
   <p:cSld>
     <p:bg>
       <p:bgPr>
@@ -4496,7 +4588,14 @@
         <p:cNvGrpSpPr/>
         <p:nvPr/>
       </p:nvGrpSpPr>
-      <p:grpSpPr/>
+      <p:grpSpPr>
+        <a:xfrm>
+          <a:off x="0" y="0"/>
+          <a:ext cx="0" cy="0"/>
+          <a:chOff x="0" y="0"/>
+          <a:chExt cx="0" cy="0"/>
+        </a:xfrm>
+      </p:grpSpPr>
       <p:sp>
         <p:nvSpPr>
           <p:cNvPr id="2" name="TextBox 1"/>
@@ -4655,6 +4754,7 @@
           <a:lstStyle/>
           <a:p>
             <a:pPr algn="ctr"/>
+            <a:endParaRPr/>
           </a:p>
         </p:txBody>
       </p:sp>
@@ -4668,7 +4768,7 @@
         </p:nvGraphicFramePr>
         <p:xfrm>
           <a:off x="822960" y="1691640"/>
-          <a:ext cx="10515599" cy="1645920"/>
+          <a:ext cx="10515599" cy="1700784"/>
         </p:xfrm>
         <a:graphic>
           <a:graphicData uri="http://schemas.openxmlformats.org/drawingml/2006/table">
@@ -4677,10 +4777,34 @@
                 <a:tableStyleId>{5C22544A-7EE6-4342-B048-85BDC9FD1C3A}</a:tableStyleId>
               </a:tblPr>
               <a:tblGrid>
-                <a:gridCol w="4754880"/>
-                <a:gridCol w="1828800"/>
-                <a:gridCol w="1828800"/>
-                <a:gridCol w="2103119"/>
+                <a:gridCol w="4754880">
+                  <a:extLst>
+                    <a:ext uri="{9D8B030D-6E8A-4147-A177-3AD203B41FA5}">
+                      <a16:colId xmlns:a16="http://schemas.microsoft.com/office/drawing/2014/main" val="20000"/>
+                    </a:ext>
+                  </a:extLst>
+                </a:gridCol>
+                <a:gridCol w="1828800">
+                  <a:extLst>
+                    <a:ext uri="{9D8B030D-6E8A-4147-A177-3AD203B41FA5}">
+                      <a16:colId xmlns:a16="http://schemas.microsoft.com/office/drawing/2014/main" val="20001"/>
+                    </a:ext>
+                  </a:extLst>
+                </a:gridCol>
+                <a:gridCol w="1828800">
+                  <a:extLst>
+                    <a:ext uri="{9D8B030D-6E8A-4147-A177-3AD203B41FA5}">
+                      <a16:colId xmlns:a16="http://schemas.microsoft.com/office/drawing/2014/main" val="20002"/>
+                    </a:ext>
+                  </a:extLst>
+                </a:gridCol>
+                <a:gridCol w="2103119">
+                  <a:extLst>
+                    <a:ext uri="{9D8B030D-6E8A-4147-A177-3AD203B41FA5}">
+                      <a16:colId xmlns:a16="http://schemas.microsoft.com/office/drawing/2014/main" val="20003"/>
+                    </a:ext>
+                  </a:extLst>
+                </a:gridCol>
               </a:tblGrid>
               <a:tr h="274320">
                 <a:tc>
@@ -4689,6 +4813,7 @@
                     <a:lstStyle/>
                     <a:p>
                       <a:pPr algn="l"/>
+                      <a:endParaRPr/>
                     </a:p>
                   </a:txBody>
                   <a:tcPr marL="82296" marR="82296" marT="27432" marB="27432" anchor="ctr">
@@ -4766,6 +4891,11 @@
                     </a:solidFill>
                   </a:tcPr>
                 </a:tc>
+                <a:extLst>
+                  <a:ext uri="{0D108BD9-81ED-4DB2-BD59-A6C34878D82A}">
+                    <a16:rowId xmlns:a16="http://schemas.microsoft.com/office/drawing/2014/main" val="10000"/>
+                  </a:ext>
+                </a:extLst>
               </a:tr>
               <a:tr h="274320">
                 <a:tc>
@@ -4860,6 +4990,11 @@
                     </a:solidFill>
                   </a:tcPr>
                 </a:tc>
+                <a:extLst>
+                  <a:ext uri="{0D108BD9-81ED-4DB2-BD59-A6C34878D82A}">
+                    <a16:rowId xmlns:a16="http://schemas.microsoft.com/office/drawing/2014/main" val="10001"/>
+                  </a:ext>
+                </a:extLst>
               </a:tr>
               <a:tr h="274320">
                 <a:tc>
@@ -4954,6 +5089,11 @@
                     </a:solidFill>
                   </a:tcPr>
                 </a:tc>
+                <a:extLst>
+                  <a:ext uri="{0D108BD9-81ED-4DB2-BD59-A6C34878D82A}">
+                    <a16:rowId xmlns:a16="http://schemas.microsoft.com/office/drawing/2014/main" val="10002"/>
+                  </a:ext>
+                </a:extLst>
               </a:tr>
               <a:tr h="274320">
                 <a:tc>
@@ -5048,6 +5188,11 @@
                     </a:solidFill>
                   </a:tcPr>
                 </a:tc>
+                <a:extLst>
+                  <a:ext uri="{0D108BD9-81ED-4DB2-BD59-A6C34878D82A}">
+                    <a16:rowId xmlns:a16="http://schemas.microsoft.com/office/drawing/2014/main" val="10003"/>
+                  </a:ext>
+                </a:extLst>
               </a:tr>
               <a:tr h="274320">
                 <a:tc>
@@ -5142,6 +5287,11 @@
                     </a:solidFill>
                   </a:tcPr>
                 </a:tc>
+                <a:extLst>
+                  <a:ext uri="{0D108BD9-81ED-4DB2-BD59-A6C34878D82A}">
+                    <a16:rowId xmlns:a16="http://schemas.microsoft.com/office/drawing/2014/main" val="10004"/>
+                  </a:ext>
+                </a:extLst>
               </a:tr>
               <a:tr h="274320">
                 <a:tc>
@@ -5236,6 +5386,11 @@
                     </a:solidFill>
                   </a:tcPr>
                 </a:tc>
+                <a:extLst>
+                  <a:ext uri="{0D108BD9-81ED-4DB2-BD59-A6C34878D82A}">
+                    <a16:rowId xmlns:a16="http://schemas.microsoft.com/office/drawing/2014/main" val="10005"/>
+                  </a:ext>
+                </a:extLst>
               </a:tr>
             </a:tbl>
           </a:graphicData>
@@ -5260,10 +5415,34 @@
                 <a:tableStyleId>{5C22544A-7EE6-4342-B048-85BDC9FD1C3A}</a:tableStyleId>
               </a:tblPr>
               <a:tblGrid>
-                <a:gridCol w="2377440"/>
-                <a:gridCol w="1188720"/>
-                <a:gridCol w="1188720"/>
-                <a:gridCol w="731520"/>
+                <a:gridCol w="2377440">
+                  <a:extLst>
+                    <a:ext uri="{9D8B030D-6E8A-4147-A177-3AD203B41FA5}">
+                      <a16:colId xmlns:a16="http://schemas.microsoft.com/office/drawing/2014/main" val="20000"/>
+                    </a:ext>
+                  </a:extLst>
+                </a:gridCol>
+                <a:gridCol w="1188720">
+                  <a:extLst>
+                    <a:ext uri="{9D8B030D-6E8A-4147-A177-3AD203B41FA5}">
+                      <a16:colId xmlns:a16="http://schemas.microsoft.com/office/drawing/2014/main" val="20001"/>
+                    </a:ext>
+                  </a:extLst>
+                </a:gridCol>
+                <a:gridCol w="1188720">
+                  <a:extLst>
+                    <a:ext uri="{9D8B030D-6E8A-4147-A177-3AD203B41FA5}">
+                      <a16:colId xmlns:a16="http://schemas.microsoft.com/office/drawing/2014/main" val="20002"/>
+                    </a:ext>
+                  </a:extLst>
+                </a:gridCol>
+                <a:gridCol w="731520">
+                  <a:extLst>
+                    <a:ext uri="{9D8B030D-6E8A-4147-A177-3AD203B41FA5}">
+                      <a16:colId xmlns:a16="http://schemas.microsoft.com/office/drawing/2014/main" val="20003"/>
+                    </a:ext>
+                  </a:extLst>
+                </a:gridCol>
               </a:tblGrid>
               <a:tr h="274320">
                 <a:tc>
@@ -5358,6 +5537,11 @@
                     </a:solidFill>
                   </a:tcPr>
                 </a:tc>
+                <a:extLst>
+                  <a:ext uri="{0D108BD9-81ED-4DB2-BD59-A6C34878D82A}">
+                    <a16:rowId xmlns:a16="http://schemas.microsoft.com/office/drawing/2014/main" val="10000"/>
+                  </a:ext>
+                </a:extLst>
               </a:tr>
               <a:tr h="274320">
                 <a:tc>
@@ -5452,6 +5636,11 @@
                     </a:solidFill>
                   </a:tcPr>
                 </a:tc>
+                <a:extLst>
+                  <a:ext uri="{0D108BD9-81ED-4DB2-BD59-A6C34878D82A}">
+                    <a16:rowId xmlns:a16="http://schemas.microsoft.com/office/drawing/2014/main" val="10001"/>
+                  </a:ext>
+                </a:extLst>
               </a:tr>
               <a:tr h="274320">
                 <a:tc>
@@ -5546,6 +5735,11 @@
                     </a:solidFill>
                   </a:tcPr>
                 </a:tc>
+                <a:extLst>
+                  <a:ext uri="{0D108BD9-81ED-4DB2-BD59-A6C34878D82A}">
+                    <a16:rowId xmlns:a16="http://schemas.microsoft.com/office/drawing/2014/main" val="10002"/>
+                  </a:ext>
+                </a:extLst>
               </a:tr>
               <a:tr h="274320">
                 <a:tc>
@@ -5640,6 +5834,11 @@
                     </a:solidFill>
                   </a:tcPr>
                 </a:tc>
+                <a:extLst>
+                  <a:ext uri="{0D108BD9-81ED-4DB2-BD59-A6C34878D82A}">
+                    <a16:rowId xmlns:a16="http://schemas.microsoft.com/office/drawing/2014/main" val="10003"/>
+                  </a:ext>
+                </a:extLst>
               </a:tr>
               <a:tr h="274320">
                 <a:tc>
@@ -5734,6 +5933,11 @@
                     </a:solidFill>
                   </a:tcPr>
                 </a:tc>
+                <a:extLst>
+                  <a:ext uri="{0D108BD9-81ED-4DB2-BD59-A6C34878D82A}">
+                    <a16:rowId xmlns:a16="http://schemas.microsoft.com/office/drawing/2014/main" val="10004"/>
+                  </a:ext>
+                </a:extLst>
               </a:tr>
             </a:tbl>
           </a:graphicData>
@@ -5784,6 +5988,7 @@
           <a:lstStyle/>
           <a:p>
             <a:pPr algn="ctr"/>
+            <a:endParaRPr/>
           </a:p>
         </p:txBody>
       </p:sp>
@@ -5922,7 +6127,7 @@
 </file>
 
 <file path=ppt/slides/slide14.xml><?xml version="1.0" encoding="utf-8"?>
-<p:sld xmlns:a="http://schemas.openxmlformats.org/drawingml/2006/main" xmlns:p="http://schemas.openxmlformats.org/presentationml/2006/main" xmlns:r="http://schemas.openxmlformats.org/officeDocument/2006/relationships">
+<p:sld xmlns:a="http://schemas.openxmlformats.org/drawingml/2006/main" xmlns:r="http://schemas.openxmlformats.org/officeDocument/2006/relationships" xmlns:p="http://schemas.openxmlformats.org/presentationml/2006/main">
   <p:cSld>
     <p:bg>
       <p:bgPr>
@@ -5938,7 +6143,14 @@
         <p:cNvGrpSpPr/>
         <p:nvPr/>
       </p:nvGrpSpPr>
-      <p:grpSpPr/>
+      <p:grpSpPr>
+        <a:xfrm>
+          <a:off x="0" y="0"/>
+          <a:ext cx="0" cy="0"/>
+          <a:chOff x="0" y="0"/>
+          <a:chExt cx="0" cy="0"/>
+        </a:xfrm>
+      </p:grpSpPr>
       <p:sp>
         <p:nvSpPr>
           <p:cNvPr id="2" name="TextBox 1"/>
@@ -6097,6 +6309,7 @@
           <a:lstStyle/>
           <a:p>
             <a:pPr algn="ctr"/>
+            <a:endParaRPr/>
           </a:p>
         </p:txBody>
       </p:sp>
@@ -6119,10 +6332,34 @@
                 <a:tableStyleId>{5C22544A-7EE6-4342-B048-85BDC9FD1C3A}</a:tableStyleId>
               </a:tblPr>
               <a:tblGrid>
-                <a:gridCol w="4779818"/>
-                <a:gridCol w="1720734"/>
-                <a:gridCol w="1720734"/>
-                <a:gridCol w="2294312"/>
+                <a:gridCol w="4779818">
+                  <a:extLst>
+                    <a:ext uri="{9D8B030D-6E8A-4147-A177-3AD203B41FA5}">
+                      <a16:colId xmlns:a16="http://schemas.microsoft.com/office/drawing/2014/main" val="20000"/>
+                    </a:ext>
+                  </a:extLst>
+                </a:gridCol>
+                <a:gridCol w="1720734">
+                  <a:extLst>
+                    <a:ext uri="{9D8B030D-6E8A-4147-A177-3AD203B41FA5}">
+                      <a16:colId xmlns:a16="http://schemas.microsoft.com/office/drawing/2014/main" val="20001"/>
+                    </a:ext>
+                  </a:extLst>
+                </a:gridCol>
+                <a:gridCol w="1720734">
+                  <a:extLst>
+                    <a:ext uri="{9D8B030D-6E8A-4147-A177-3AD203B41FA5}">
+                      <a16:colId xmlns:a16="http://schemas.microsoft.com/office/drawing/2014/main" val="20002"/>
+                    </a:ext>
+                  </a:extLst>
+                </a:gridCol>
+                <a:gridCol w="2294312">
+                  <a:extLst>
+                    <a:ext uri="{9D8B030D-6E8A-4147-A177-3AD203B41FA5}">
+                      <a16:colId xmlns:a16="http://schemas.microsoft.com/office/drawing/2014/main" val="20003"/>
+                    </a:ext>
+                  </a:extLst>
+                </a:gridCol>
               </a:tblGrid>
               <a:tr h="274320">
                 <a:tc>
@@ -6217,6 +6454,11 @@
                     </a:solidFill>
                   </a:tcPr>
                 </a:tc>
+                <a:extLst>
+                  <a:ext uri="{0D108BD9-81ED-4DB2-BD59-A6C34878D82A}">
+                    <a16:rowId xmlns:a16="http://schemas.microsoft.com/office/drawing/2014/main" val="10000"/>
+                  </a:ext>
+                </a:extLst>
               </a:tr>
               <a:tr h="274320">
                 <a:tc>
@@ -6311,6 +6553,11 @@
                     </a:solidFill>
                   </a:tcPr>
                 </a:tc>
+                <a:extLst>
+                  <a:ext uri="{0D108BD9-81ED-4DB2-BD59-A6C34878D82A}">
+                    <a16:rowId xmlns:a16="http://schemas.microsoft.com/office/drawing/2014/main" val="10001"/>
+                  </a:ext>
+                </a:extLst>
               </a:tr>
               <a:tr h="274320">
                 <a:tc>
@@ -6405,6 +6652,11 @@
                     </a:solidFill>
                   </a:tcPr>
                 </a:tc>
+                <a:extLst>
+                  <a:ext uri="{0D108BD9-81ED-4DB2-BD59-A6C34878D82A}">
+                    <a16:rowId xmlns:a16="http://schemas.microsoft.com/office/drawing/2014/main" val="10002"/>
+                  </a:ext>
+                </a:extLst>
               </a:tr>
               <a:tr h="274320">
                 <a:tc>
@@ -6499,6 +6751,11 @@
                     </a:solidFill>
                   </a:tcPr>
                 </a:tc>
+                <a:extLst>
+                  <a:ext uri="{0D108BD9-81ED-4DB2-BD59-A6C34878D82A}">
+                    <a16:rowId xmlns:a16="http://schemas.microsoft.com/office/drawing/2014/main" val="10003"/>
+                  </a:ext>
+                </a:extLst>
               </a:tr>
             </a:tbl>
           </a:graphicData>
@@ -6549,6 +6806,7 @@
           <a:lstStyle/>
           <a:p>
             <a:pPr algn="ctr"/>
+            <a:endParaRPr/>
           </a:p>
         </p:txBody>
       </p:sp>
@@ -6595,15 +6853,12 @@
                 <a:spcPct val="125000"/>
               </a:lnSpc>
             </a:pPr>
-            <a:r>
-              <a:rPr sz="1300" b="0">
-                <a:solidFill>
-                  <a:srgbClr val="3C4947"/>
-                </a:solidFill>
-                <a:latin typeface="맑은 고딕"/>
-              </a:rPr>
-              <a:t/>
-            </a:r>
+            <a:endParaRPr sz="1300" b="1">
+              <a:solidFill>
+                <a:srgbClr val="131A19"/>
+              </a:solidFill>
+              <a:latin typeface="맑은 고딕"/>
+            </a:endParaRPr>
           </a:p>
           <a:p>
             <a:pPr algn="l">
@@ -6648,7 +6903,7 @@
 </file>
 
 <file path=ppt/slides/slide15.xml><?xml version="1.0" encoding="utf-8"?>
-<p:sld xmlns:a="http://schemas.openxmlformats.org/drawingml/2006/main" xmlns:p="http://schemas.openxmlformats.org/presentationml/2006/main" xmlns:r="http://schemas.openxmlformats.org/officeDocument/2006/relationships">
+<p:sld xmlns:a="http://schemas.openxmlformats.org/drawingml/2006/main" xmlns:r="http://schemas.openxmlformats.org/officeDocument/2006/relationships" xmlns:p="http://schemas.openxmlformats.org/presentationml/2006/main">
   <p:cSld>
     <p:bg>
       <p:bgPr>
@@ -6664,7 +6919,14 @@
         <p:cNvGrpSpPr/>
         <p:nvPr/>
       </p:nvGrpSpPr>
-      <p:grpSpPr/>
+      <p:grpSpPr>
+        <a:xfrm>
+          <a:off x="0" y="0"/>
+          <a:ext cx="0" cy="0"/>
+          <a:chOff x="0" y="0"/>
+          <a:chExt cx="0" cy="0"/>
+        </a:xfrm>
+      </p:grpSpPr>
       <p:sp>
         <p:nvSpPr>
           <p:cNvPr id="2" name="TextBox 1"/>
@@ -6823,6 +7085,7 @@
           <a:lstStyle/>
           <a:p>
             <a:pPr algn="ctr"/>
+            <a:endParaRPr/>
           </a:p>
         </p:txBody>
       </p:sp>
@@ -6942,6 +7205,7 @@
           <a:lstStyle/>
           <a:p>
             <a:pPr algn="ctr"/>
+            <a:endParaRPr/>
           </a:p>
         </p:txBody>
       </p:sp>
@@ -7069,6 +7333,7 @@
           <a:lstStyle/>
           <a:p>
             <a:pPr algn="ctr"/>
+            <a:endParaRPr/>
           </a:p>
         </p:txBody>
       </p:sp>
@@ -7197,6 +7462,7 @@
           <a:lstStyle/>
           <a:p>
             <a:pPr algn="ctr"/>
+            <a:endParaRPr/>
           </a:p>
         </p:txBody>
       </p:sp>
@@ -7324,6 +7590,7 @@
           <a:lstStyle/>
           <a:p>
             <a:pPr algn="ctr"/>
+            <a:endParaRPr/>
           </a:p>
         </p:txBody>
       </p:sp>
@@ -7451,6 +7718,7 @@
           <a:lstStyle/>
           <a:p>
             <a:pPr algn="ctr"/>
+            <a:endParaRPr/>
           </a:p>
         </p:txBody>
       </p:sp>
@@ -7577,6 +7845,7 @@
           <a:lstStyle/>
           <a:p>
             <a:pPr algn="ctr"/>
+            <a:endParaRPr/>
           </a:p>
         </p:txBody>
       </p:sp>
@@ -7699,7 +7968,7 @@
 </file>
 
 <file path=ppt/slides/slide16.xml><?xml version="1.0" encoding="utf-8"?>
-<p:sld xmlns:a="http://schemas.openxmlformats.org/drawingml/2006/main" xmlns:p="http://schemas.openxmlformats.org/presentationml/2006/main" xmlns:r="http://schemas.openxmlformats.org/officeDocument/2006/relationships">
+<p:sld xmlns:a="http://schemas.openxmlformats.org/drawingml/2006/main" xmlns:r="http://schemas.openxmlformats.org/officeDocument/2006/relationships" xmlns:p="http://schemas.openxmlformats.org/presentationml/2006/main">
   <p:cSld>
     <p:bg>
       <p:bgPr>
@@ -7715,7 +7984,14 @@
         <p:cNvGrpSpPr/>
         <p:nvPr/>
       </p:nvGrpSpPr>
-      <p:grpSpPr/>
+      <p:grpSpPr>
+        <a:xfrm>
+          <a:off x="0" y="0"/>
+          <a:ext cx="0" cy="0"/>
+          <a:chOff x="0" y="0"/>
+          <a:chExt cx="0" cy="0"/>
+        </a:xfrm>
+      </p:grpSpPr>
       <p:sp>
         <p:nvSpPr>
           <p:cNvPr id="2" name="TextBox 1"/>
@@ -7874,6 +8150,7 @@
           <a:lstStyle/>
           <a:p>
             <a:pPr algn="ctr"/>
+            <a:endParaRPr/>
           </a:p>
         </p:txBody>
       </p:sp>
@@ -7920,10 +8197,34 @@
                 <a:tableStyleId>{5C22544A-7EE6-4342-B048-85BDC9FD1C3A}</a:tableStyleId>
               </a:tblPr>
               <a:tblGrid>
-                <a:gridCol w="2011680"/>
-                <a:gridCol w="2194560"/>
-                <a:gridCol w="1463040"/>
-                <a:gridCol w="4846320"/>
+                <a:gridCol w="2011680">
+                  <a:extLst>
+                    <a:ext uri="{9D8B030D-6E8A-4147-A177-3AD203B41FA5}">
+                      <a16:colId xmlns:a16="http://schemas.microsoft.com/office/drawing/2014/main" val="20000"/>
+                    </a:ext>
+                  </a:extLst>
+                </a:gridCol>
+                <a:gridCol w="2194560">
+                  <a:extLst>
+                    <a:ext uri="{9D8B030D-6E8A-4147-A177-3AD203B41FA5}">
+                      <a16:colId xmlns:a16="http://schemas.microsoft.com/office/drawing/2014/main" val="20001"/>
+                    </a:ext>
+                  </a:extLst>
+                </a:gridCol>
+                <a:gridCol w="1463040">
+                  <a:extLst>
+                    <a:ext uri="{9D8B030D-6E8A-4147-A177-3AD203B41FA5}">
+                      <a16:colId xmlns:a16="http://schemas.microsoft.com/office/drawing/2014/main" val="20002"/>
+                    </a:ext>
+                  </a:extLst>
+                </a:gridCol>
+                <a:gridCol w="4846320">
+                  <a:extLst>
+                    <a:ext uri="{9D8B030D-6E8A-4147-A177-3AD203B41FA5}">
+                      <a16:colId xmlns:a16="http://schemas.microsoft.com/office/drawing/2014/main" val="20003"/>
+                    </a:ext>
+                  </a:extLst>
+                </a:gridCol>
               </a:tblGrid>
               <a:tr h="274320">
                 <a:tc>
@@ -8018,6 +8319,11 @@
                     </a:solidFill>
                   </a:tcPr>
                 </a:tc>
+                <a:extLst>
+                  <a:ext uri="{0D108BD9-81ED-4DB2-BD59-A6C34878D82A}">
+                    <a16:rowId xmlns:a16="http://schemas.microsoft.com/office/drawing/2014/main" val="10000"/>
+                  </a:ext>
+                </a:extLst>
               </a:tr>
               <a:tr h="274320">
                 <a:tc>
@@ -8112,6 +8418,11 @@
                     </a:solidFill>
                   </a:tcPr>
                 </a:tc>
+                <a:extLst>
+                  <a:ext uri="{0D108BD9-81ED-4DB2-BD59-A6C34878D82A}">
+                    <a16:rowId xmlns:a16="http://schemas.microsoft.com/office/drawing/2014/main" val="10001"/>
+                  </a:ext>
+                </a:extLst>
               </a:tr>
               <a:tr h="274320">
                 <a:tc>
@@ -8206,6 +8517,11 @@
                     </a:solidFill>
                   </a:tcPr>
                 </a:tc>
+                <a:extLst>
+                  <a:ext uri="{0D108BD9-81ED-4DB2-BD59-A6C34878D82A}">
+                    <a16:rowId xmlns:a16="http://schemas.microsoft.com/office/drawing/2014/main" val="10002"/>
+                  </a:ext>
+                </a:extLst>
               </a:tr>
               <a:tr h="274320">
                 <a:tc>
@@ -8300,6 +8616,11 @@
                     </a:solidFill>
                   </a:tcPr>
                 </a:tc>
+                <a:extLst>
+                  <a:ext uri="{0D108BD9-81ED-4DB2-BD59-A6C34878D82A}">
+                    <a16:rowId xmlns:a16="http://schemas.microsoft.com/office/drawing/2014/main" val="10003"/>
+                  </a:ext>
+                </a:extLst>
               </a:tr>
               <a:tr h="274320">
                 <a:tc>
@@ -8394,6 +8715,11 @@
                     </a:solidFill>
                   </a:tcPr>
                 </a:tc>
+                <a:extLst>
+                  <a:ext uri="{0D108BD9-81ED-4DB2-BD59-A6C34878D82A}">
+                    <a16:rowId xmlns:a16="http://schemas.microsoft.com/office/drawing/2014/main" val="10004"/>
+                  </a:ext>
+                </a:extLst>
               </a:tr>
             </a:tbl>
           </a:graphicData>
@@ -8447,7 +8773,7 @@
 </file>
 
 <file path=ppt/slides/slide17.xml><?xml version="1.0" encoding="utf-8"?>
-<p:sld xmlns:a="http://schemas.openxmlformats.org/drawingml/2006/main" xmlns:p="http://schemas.openxmlformats.org/presentationml/2006/main" xmlns:r="http://schemas.openxmlformats.org/officeDocument/2006/relationships">
+<p:sld xmlns:a="http://schemas.openxmlformats.org/drawingml/2006/main" xmlns:r="http://schemas.openxmlformats.org/officeDocument/2006/relationships" xmlns:p="http://schemas.openxmlformats.org/presentationml/2006/main">
   <p:cSld>
     <p:bg>
       <p:bgPr>
@@ -8463,7 +8789,14 @@
         <p:cNvGrpSpPr/>
         <p:nvPr/>
       </p:nvGrpSpPr>
-      <p:grpSpPr/>
+      <p:grpSpPr>
+        <a:xfrm>
+          <a:off x="0" y="0"/>
+          <a:ext cx="0" cy="0"/>
+          <a:chOff x="0" y="0"/>
+          <a:chExt cx="0" cy="0"/>
+        </a:xfrm>
+      </p:grpSpPr>
       <p:sp>
         <p:nvSpPr>
           <p:cNvPr id="2" name="TextBox 1"/>
@@ -8622,6 +8955,7 @@
           <a:lstStyle/>
           <a:p>
             <a:pPr algn="ctr"/>
+            <a:endParaRPr/>
           </a:p>
         </p:txBody>
       </p:sp>
@@ -8644,9 +8978,27 @@
                 <a:tableStyleId>{5C22544A-7EE6-4342-B048-85BDC9FD1C3A}</a:tableStyleId>
               </a:tblPr>
               <a:tblGrid>
-                <a:gridCol w="3291840"/>
-                <a:gridCol w="1371600"/>
-                <a:gridCol w="6400800"/>
+                <a:gridCol w="3291840">
+                  <a:extLst>
+                    <a:ext uri="{9D8B030D-6E8A-4147-A177-3AD203B41FA5}">
+                      <a16:colId xmlns:a16="http://schemas.microsoft.com/office/drawing/2014/main" val="20000"/>
+                    </a:ext>
+                  </a:extLst>
+                </a:gridCol>
+                <a:gridCol w="1371600">
+                  <a:extLst>
+                    <a:ext uri="{9D8B030D-6E8A-4147-A177-3AD203B41FA5}">
+                      <a16:colId xmlns:a16="http://schemas.microsoft.com/office/drawing/2014/main" val="20001"/>
+                    </a:ext>
+                  </a:extLst>
+                </a:gridCol>
+                <a:gridCol w="6400800">
+                  <a:extLst>
+                    <a:ext uri="{9D8B030D-6E8A-4147-A177-3AD203B41FA5}">
+                      <a16:colId xmlns:a16="http://schemas.microsoft.com/office/drawing/2014/main" val="20002"/>
+                    </a:ext>
+                  </a:extLst>
+                </a:gridCol>
               </a:tblGrid>
               <a:tr h="274320">
                 <a:tc>
@@ -8718,6 +9070,11 @@
                     </a:solidFill>
                   </a:tcPr>
                 </a:tc>
+                <a:extLst>
+                  <a:ext uri="{0D108BD9-81ED-4DB2-BD59-A6C34878D82A}">
+                    <a16:rowId xmlns:a16="http://schemas.microsoft.com/office/drawing/2014/main" val="10000"/>
+                  </a:ext>
+                </a:extLst>
               </a:tr>
               <a:tr h="274320">
                 <a:tc>
@@ -8789,6 +9146,11 @@
                     </a:solidFill>
                   </a:tcPr>
                 </a:tc>
+                <a:extLst>
+                  <a:ext uri="{0D108BD9-81ED-4DB2-BD59-A6C34878D82A}">
+                    <a16:rowId xmlns:a16="http://schemas.microsoft.com/office/drawing/2014/main" val="10001"/>
+                  </a:ext>
+                </a:extLst>
               </a:tr>
               <a:tr h="274320">
                 <a:tc>
@@ -8860,6 +9222,11 @@
                     </a:solidFill>
                   </a:tcPr>
                 </a:tc>
+                <a:extLst>
+                  <a:ext uri="{0D108BD9-81ED-4DB2-BD59-A6C34878D82A}">
+                    <a16:rowId xmlns:a16="http://schemas.microsoft.com/office/drawing/2014/main" val="10002"/>
+                  </a:ext>
+                </a:extLst>
               </a:tr>
               <a:tr h="274320">
                 <a:tc>
@@ -8931,6 +9298,11 @@
                     </a:solidFill>
                   </a:tcPr>
                 </a:tc>
+                <a:extLst>
+                  <a:ext uri="{0D108BD9-81ED-4DB2-BD59-A6C34878D82A}">
+                    <a16:rowId xmlns:a16="http://schemas.microsoft.com/office/drawing/2014/main" val="10003"/>
+                  </a:ext>
+                </a:extLst>
               </a:tr>
               <a:tr h="274320">
                 <a:tc>
@@ -9002,6 +9374,11 @@
                     </a:solidFill>
                   </a:tcPr>
                 </a:tc>
+                <a:extLst>
+                  <a:ext uri="{0D108BD9-81ED-4DB2-BD59-A6C34878D82A}">
+                    <a16:rowId xmlns:a16="http://schemas.microsoft.com/office/drawing/2014/main" val="10004"/>
+                  </a:ext>
+                </a:extLst>
               </a:tr>
               <a:tr h="274320">
                 <a:tc>
@@ -9073,6 +9450,11 @@
                     </a:solidFill>
                   </a:tcPr>
                 </a:tc>
+                <a:extLst>
+                  <a:ext uri="{0D108BD9-81ED-4DB2-BD59-A6C34878D82A}">
+                    <a16:rowId xmlns:a16="http://schemas.microsoft.com/office/drawing/2014/main" val="10005"/>
+                  </a:ext>
+                </a:extLst>
               </a:tr>
               <a:tr h="274320">
                 <a:tc>
@@ -9144,6 +9526,11 @@
                     </a:solidFill>
                   </a:tcPr>
                 </a:tc>
+                <a:extLst>
+                  <a:ext uri="{0D108BD9-81ED-4DB2-BD59-A6C34878D82A}">
+                    <a16:rowId xmlns:a16="http://schemas.microsoft.com/office/drawing/2014/main" val="10006"/>
+                  </a:ext>
+                </a:extLst>
               </a:tr>
               <a:tr h="274320">
                 <a:tc>
@@ -9215,6 +9602,11 @@
                     </a:solidFill>
                   </a:tcPr>
                 </a:tc>
+                <a:extLst>
+                  <a:ext uri="{0D108BD9-81ED-4DB2-BD59-A6C34878D82A}">
+                    <a16:rowId xmlns:a16="http://schemas.microsoft.com/office/drawing/2014/main" val="10007"/>
+                  </a:ext>
+                </a:extLst>
               </a:tr>
               <a:tr h="274320">
                 <a:tc>
@@ -9286,6 +9678,11 @@
                     </a:solidFill>
                   </a:tcPr>
                 </a:tc>
+                <a:extLst>
+                  <a:ext uri="{0D108BD9-81ED-4DB2-BD59-A6C34878D82A}">
+                    <a16:rowId xmlns:a16="http://schemas.microsoft.com/office/drawing/2014/main" val="10008"/>
+                  </a:ext>
+                </a:extLst>
               </a:tr>
               <a:tr h="274320">
                 <a:tc>
@@ -9357,6 +9754,11 @@
                     </a:solidFill>
                   </a:tcPr>
                 </a:tc>
+                <a:extLst>
+                  <a:ext uri="{0D108BD9-81ED-4DB2-BD59-A6C34878D82A}">
+                    <a16:rowId xmlns:a16="http://schemas.microsoft.com/office/drawing/2014/main" val="10009"/>
+                  </a:ext>
+                </a:extLst>
               </a:tr>
               <a:tr h="274320">
                 <a:tc>
@@ -9428,6 +9830,11 @@
                     </a:solidFill>
                   </a:tcPr>
                 </a:tc>
+                <a:extLst>
+                  <a:ext uri="{0D108BD9-81ED-4DB2-BD59-A6C34878D82A}">
+                    <a16:rowId xmlns:a16="http://schemas.microsoft.com/office/drawing/2014/main" val="10010"/>
+                  </a:ext>
+                </a:extLst>
               </a:tr>
               <a:tr h="274320">
                 <a:tc>
@@ -9499,6 +9906,11 @@
                     </a:solidFill>
                   </a:tcPr>
                 </a:tc>
+                <a:extLst>
+                  <a:ext uri="{0D108BD9-81ED-4DB2-BD59-A6C34878D82A}">
+                    <a16:rowId xmlns:a16="http://schemas.microsoft.com/office/drawing/2014/main" val="10011"/>
+                  </a:ext>
+                </a:extLst>
               </a:tr>
               <a:tr h="274320">
                 <a:tc>
@@ -9570,6 +9982,11 @@
                     </a:solidFill>
                   </a:tcPr>
                 </a:tc>
+                <a:extLst>
+                  <a:ext uri="{0D108BD9-81ED-4DB2-BD59-A6C34878D82A}">
+                    <a16:rowId xmlns:a16="http://schemas.microsoft.com/office/drawing/2014/main" val="10012"/>
+                  </a:ext>
+                </a:extLst>
               </a:tr>
               <a:tr h="274320">
                 <a:tc>
@@ -9641,6 +10058,11 @@
                     </a:solidFill>
                   </a:tcPr>
                 </a:tc>
+                <a:extLst>
+                  <a:ext uri="{0D108BD9-81ED-4DB2-BD59-A6C34878D82A}">
+                    <a16:rowId xmlns:a16="http://schemas.microsoft.com/office/drawing/2014/main" val="10013"/>
+                  </a:ext>
+                </a:extLst>
               </a:tr>
             </a:tbl>
           </a:graphicData>
@@ -9694,7 +10116,7 @@
 </file>
 
 <file path=ppt/slides/slide18.xml><?xml version="1.0" encoding="utf-8"?>
-<p:sld xmlns:a="http://schemas.openxmlformats.org/drawingml/2006/main" xmlns:p="http://schemas.openxmlformats.org/presentationml/2006/main" xmlns:r="http://schemas.openxmlformats.org/officeDocument/2006/relationships">
+<p:sld xmlns:a="http://schemas.openxmlformats.org/drawingml/2006/main" xmlns:r="http://schemas.openxmlformats.org/officeDocument/2006/relationships" xmlns:p="http://schemas.openxmlformats.org/presentationml/2006/main">
   <p:cSld>
     <p:bg>
       <p:bgPr>
@@ -9710,7 +10132,14 @@
         <p:cNvGrpSpPr/>
         <p:nvPr/>
       </p:nvGrpSpPr>
-      <p:grpSpPr/>
+      <p:grpSpPr>
+        <a:xfrm>
+          <a:off x="0" y="0"/>
+          <a:ext cx="0" cy="0"/>
+          <a:chOff x="0" y="0"/>
+          <a:chExt cx="0" cy="0"/>
+        </a:xfrm>
+      </p:grpSpPr>
       <p:sp>
         <p:nvSpPr>
           <p:cNvPr id="2" name="TextBox 1"/>
@@ -9869,6 +10298,7 @@
           <a:lstStyle/>
           <a:p>
             <a:pPr algn="ctr"/>
+            <a:endParaRPr/>
           </a:p>
         </p:txBody>
       </p:sp>
@@ -9917,6 +10347,7 @@
           <a:lstStyle/>
           <a:p>
             <a:pPr algn="ctr"/>
+            <a:endParaRPr/>
           </a:p>
         </p:txBody>
       </p:sp>
@@ -10044,6 +10475,7 @@
           <a:lstStyle/>
           <a:p>
             <a:pPr algn="ctr"/>
+            <a:endParaRPr/>
           </a:p>
         </p:txBody>
       </p:sp>
@@ -10170,6 +10602,7 @@
           <a:lstStyle/>
           <a:p>
             <a:pPr algn="ctr"/>
+            <a:endParaRPr/>
           </a:p>
         </p:txBody>
       </p:sp>
@@ -10296,6 +10729,7 @@
           <a:lstStyle/>
           <a:p>
             <a:pPr algn="ctr"/>
+            <a:endParaRPr/>
           </a:p>
         </p:txBody>
       </p:sp>
@@ -10387,7 +10821,7 @@
 </file>
 
 <file path=ppt/slides/slide2.xml><?xml version="1.0" encoding="utf-8"?>
-<p:sld xmlns:a="http://schemas.openxmlformats.org/drawingml/2006/main" xmlns:p="http://schemas.openxmlformats.org/presentationml/2006/main" xmlns:r="http://schemas.openxmlformats.org/officeDocument/2006/relationships">
+<p:sld xmlns:a="http://schemas.openxmlformats.org/drawingml/2006/main" xmlns:r="http://schemas.openxmlformats.org/officeDocument/2006/relationships" xmlns:p="http://schemas.openxmlformats.org/presentationml/2006/main">
   <p:cSld>
     <p:bg>
       <p:bgPr>
@@ -10403,7 +10837,14 @@
         <p:cNvGrpSpPr/>
         <p:nvPr/>
       </p:nvGrpSpPr>
-      <p:grpSpPr/>
+      <p:grpSpPr>
+        <a:xfrm>
+          <a:off x="0" y="0"/>
+          <a:ext cx="0" cy="0"/>
+          <a:chOff x="0" y="0"/>
+          <a:chExt cx="0" cy="0"/>
+        </a:xfrm>
+      </p:grpSpPr>
       <p:sp>
         <p:nvSpPr>
           <p:cNvPr id="2" name="TextBox 1"/>
@@ -10438,7 +10879,7 @@
                 </a:solidFill>
                 <a:latin typeface="Consolas"/>
               </a:rPr>
-              <a:t>Summary</a:t>
+              <a:t>Contents</a:t>
             </a:r>
           </a:p>
         </p:txBody>
@@ -10477,59 +10918,20 @@
                 </a:solidFill>
                 <a:latin typeface="맑은 고딕"/>
               </a:rPr>
-              <a:t>요약</a:t>
-            </a:r>
-          </a:p>
-        </p:txBody>
-      </p:sp>
-      <p:sp>
-        <p:nvSpPr>
-          <p:cNvPr id="4" name="TextBox 3"/>
-          <p:cNvSpPr txBox="1"/>
-          <p:nvPr/>
-        </p:nvSpPr>
-        <p:spPr>
-          <a:xfrm>
-            <a:off x="640080" y="1371600"/>
-            <a:ext cx="10972800" cy="365760"/>
-          </a:xfrm>
-          <a:prstGeom prst="rect">
-            <a:avLst/>
-          </a:prstGeom>
-          <a:noFill/>
-        </p:spPr>
-        <p:txBody>
-          <a:bodyPr wrap="square" anchor="t">
-            <a:spAutoFit/>
-          </a:bodyPr>
-          <a:lstStyle/>
-          <a:p>
-            <a:pPr algn="l">
-              <a:lnSpc>
-                <a:spcPct val="125000"/>
-              </a:lnSpc>
-            </a:pPr>
-            <a:r>
-              <a:rPr sz="1400" b="0">
-                <a:solidFill>
-                  <a:srgbClr val="66756F"/>
-                </a:solidFill>
-                <a:latin typeface="맑은 고딕"/>
-              </a:rPr>
-              <a:t>한 장으로</a:t>
-            </a:r>
-          </a:p>
-        </p:txBody>
-      </p:sp>
-      <p:sp>
-        <p:nvSpPr>
-          <p:cNvPr id="5" name="Rectangle 4"/>
+              <a:t>목차</a:t>
+            </a:r>
+          </a:p>
+        </p:txBody>
+      </p:sp>
+      <p:sp>
+        <p:nvSpPr>
+          <p:cNvPr id="4" name="Rectangle 3"/>
           <p:cNvSpPr/>
           <p:nvPr/>
         </p:nvSpPr>
         <p:spPr>
           <a:xfrm>
-            <a:off x="640080" y="1874520"/>
+            <a:off x="640080" y="1417320"/>
             <a:ext cx="10908792" cy="15240"/>
           </a:xfrm>
           <a:prstGeom prst="rect">
@@ -10562,19 +10964,20 @@
           <a:lstStyle/>
           <a:p>
             <a:pPr algn="ctr"/>
-          </a:p>
-        </p:txBody>
-      </p:sp>
-      <p:sp>
-        <p:nvSpPr>
-          <p:cNvPr id="6" name="Rounded Rectangle 5"/>
+            <a:endParaRPr/>
+          </a:p>
+        </p:txBody>
+      </p:sp>
+      <p:sp>
+        <p:nvSpPr>
+          <p:cNvPr id="5" name="Rounded Rectangle 4"/>
           <p:cNvSpPr/>
           <p:nvPr/>
         </p:nvSpPr>
         <p:spPr>
           <a:xfrm>
-            <a:off x="822960" y="1554480"/>
-            <a:ext cx="10515600" cy="960120"/>
+            <a:off x="822960" y="1600200"/>
+            <a:ext cx="10515600" cy="566928"/>
           </a:xfrm>
           <a:prstGeom prst="roundRect">
             <a:avLst>
@@ -10610,19 +11013,20 @@
           <a:lstStyle/>
           <a:p>
             <a:pPr algn="ctr"/>
-          </a:p>
-        </p:txBody>
-      </p:sp>
-      <p:sp>
-        <p:nvSpPr>
-          <p:cNvPr id="7" name="TextBox 6"/>
+            <a:endParaRPr/>
+          </a:p>
+        </p:txBody>
+      </p:sp>
+      <p:sp>
+        <p:nvSpPr>
+          <p:cNvPr id="6" name="TextBox 5"/>
           <p:cNvSpPr txBox="1"/>
           <p:nvPr/>
         </p:nvSpPr>
         <p:spPr>
           <a:xfrm>
-            <a:off x="1051560" y="1810512"/>
-            <a:ext cx="1005840" cy="365760"/>
+            <a:off x="1051560" y="1719072"/>
+            <a:ext cx="457200" cy="365760"/>
           </a:xfrm>
           <a:prstGeom prst="rect">
             <a:avLst/>
@@ -10641,27 +11045,27 @@
               </a:lnSpc>
             </a:pPr>
             <a:r>
-              <a:rPr sz="1200" b="1">
+              <a:rPr sz="1500" b="1">
                 <a:solidFill>
                   <a:srgbClr val="0B6E5E"/>
                 </a:solidFill>
                 <a:latin typeface="Consolas"/>
               </a:rPr>
-              <a:t>문제</a:t>
-            </a:r>
-          </a:p>
-        </p:txBody>
-      </p:sp>
-      <p:sp>
-        <p:nvSpPr>
-          <p:cNvPr id="8" name="TextBox 7"/>
+              <a:t>1</a:t>
+            </a:r>
+          </a:p>
+        </p:txBody>
+      </p:sp>
+      <p:sp>
+        <p:nvSpPr>
+          <p:cNvPr id="7" name="TextBox 6"/>
           <p:cNvSpPr txBox="1"/>
           <p:nvPr/>
         </p:nvSpPr>
         <p:spPr>
           <a:xfrm>
-            <a:off x="2103120" y="1664208"/>
-            <a:ext cx="9052560" cy="320040"/>
+            <a:off x="1645920" y="1728216"/>
+            <a:ext cx="2743200" cy="365760"/>
           </a:xfrm>
           <a:prstGeom prst="rect">
             <a:avLst/>
@@ -10680,27 +11084,27 @@
               </a:lnSpc>
             </a:pPr>
             <a:r>
-              <a:rPr sz="1400" b="1">
+              <a:rPr sz="1350" b="1">
                 <a:solidFill>
                   <a:srgbClr val="131A19"/>
                 </a:solidFill>
                 <a:latin typeface="맑은 고딕"/>
               </a:rPr>
-              <a:t>흐림과 노이즈가 겹쳤다  g = h * f + n</a:t>
-            </a:r>
-          </a:p>
-        </p:txBody>
-      </p:sp>
-      <p:sp>
-        <p:nvSpPr>
-          <p:cNvPr id="9" name="TextBox 8"/>
+              <a:t>파이프라인</a:t>
+            </a:r>
+          </a:p>
+        </p:txBody>
+      </p:sp>
+      <p:sp>
+        <p:nvSpPr>
+          <p:cNvPr id="8" name="TextBox 7"/>
           <p:cNvSpPr txBox="1"/>
           <p:nvPr/>
         </p:nvSpPr>
         <p:spPr>
           <a:xfrm>
-            <a:off x="2103120" y="2011680"/>
-            <a:ext cx="9052560" cy="457200"/>
+            <a:off x="4480560" y="1755648"/>
+            <a:ext cx="4937760" cy="365760"/>
           </a:xfrm>
           <a:prstGeom prst="rect">
             <a:avLst/>
@@ -10725,7 +11129,46 @@
                 </a:solidFill>
                 <a:latin typeface="맑은 고딕"/>
               </a:rPr>
-              <a:t>1일차는 노이즈만, 2일차는 흐림만이었다. 3일차는 둘이 겹쳐 각자의 답이 통하지 않는다.</a:t>
+              <a:t>무엇을 만들었나</a:t>
+            </a:r>
+          </a:p>
+        </p:txBody>
+      </p:sp>
+      <p:sp>
+        <p:nvSpPr>
+          <p:cNvPr id="9" name="TextBox 8"/>
+          <p:cNvSpPr txBox="1"/>
+          <p:nvPr/>
+        </p:nvSpPr>
+        <p:spPr>
+          <a:xfrm>
+            <a:off x="9418320" y="1755648"/>
+            <a:ext cx="1737360" cy="365760"/>
+          </a:xfrm>
+          <a:prstGeom prst="rect">
+            <a:avLst/>
+          </a:prstGeom>
+          <a:noFill/>
+        </p:spPr>
+        <p:txBody>
+          <a:bodyPr wrap="square" anchor="t">
+            <a:spAutoFit/>
+          </a:bodyPr>
+          <a:lstStyle/>
+          <a:p>
+            <a:pPr algn="r">
+              <a:lnSpc>
+                <a:spcPct val="125000"/>
+              </a:lnSpc>
+            </a:pPr>
+            <a:r>
+              <a:rPr sz="1050" b="0">
+                <a:solidFill>
+                  <a:srgbClr val="0B6E5E"/>
+                </a:solidFill>
+                <a:latin typeface="Consolas"/>
+              </a:rPr>
+              <a:t>요구사항 1</a:t>
             </a:r>
           </a:p>
         </p:txBody>
@@ -10738,8 +11181,8 @@
         </p:nvSpPr>
         <p:spPr>
           <a:xfrm>
-            <a:off x="822960" y="2606040"/>
-            <a:ext cx="10515600" cy="960120"/>
+            <a:off x="822960" y="2258568"/>
+            <a:ext cx="10515600" cy="566928"/>
           </a:xfrm>
           <a:prstGeom prst="roundRect">
             <a:avLst>
@@ -10775,6 +11218,7 @@
           <a:lstStyle/>
           <a:p>
             <a:pPr algn="ctr"/>
+            <a:endParaRPr/>
           </a:p>
         </p:txBody>
       </p:sp>
@@ -10786,8 +11230,8 @@
         </p:nvSpPr>
         <p:spPr>
           <a:xfrm>
-            <a:off x="1051560" y="2862072"/>
-            <a:ext cx="1005840" cy="365760"/>
+            <a:off x="1051560" y="2377440"/>
+            <a:ext cx="457200" cy="365760"/>
           </a:xfrm>
           <a:prstGeom prst="rect">
             <a:avLst/>
@@ -10806,13 +11250,13 @@
               </a:lnSpc>
             </a:pPr>
             <a:r>
-              <a:rPr sz="1200" b="1">
+              <a:rPr sz="1500" b="1">
                 <a:solidFill>
                   <a:srgbClr val="0B6E5E"/>
                 </a:solidFill>
                 <a:latin typeface="Consolas"/>
               </a:rPr>
-              <a:t>발견</a:t>
+              <a:t>2</a:t>
             </a:r>
           </a:p>
         </p:txBody>
@@ -10825,8 +11269,8 @@
         </p:nvSpPr>
         <p:spPr>
           <a:xfrm>
-            <a:off x="2103120" y="2715768"/>
-            <a:ext cx="9052560" cy="320040"/>
+            <a:off x="1645920" y="2386584"/>
+            <a:ext cx="2743200" cy="365760"/>
           </a:xfrm>
           <a:prstGeom prst="rect">
             <a:avLst/>
@@ -10845,13 +11289,13 @@
               </a:lnSpc>
             </a:pPr>
             <a:r>
-              <a:rPr sz="1400" b="1">
+              <a:rPr sz="1350" b="1">
                 <a:solidFill>
                   <a:srgbClr val="131A19"/>
                 </a:solidFill>
                 <a:latin typeface="맑은 고딕"/>
               </a:rPr>
-              <a:t>각자 최고인 도구를 이어 붙이면 진다 — 21.06 dB</a:t>
+              <a:t>문제와 근거</a:t>
             </a:r>
           </a:p>
         </p:txBody>
@@ -10864,8 +11308,8 @@
         </p:nvSpPr>
         <p:spPr>
           <a:xfrm>
-            <a:off x="2103120" y="3063240"/>
-            <a:ext cx="9052560" cy="457200"/>
+            <a:off x="4480560" y="2414016"/>
+            <a:ext cx="4937760" cy="365760"/>
           </a:xfrm>
           <a:prstGeom prst="rect">
             <a:avLst/>
@@ -10890,21 +11334,60 @@
                 </a:solidFill>
                 <a:latin typeface="맑은 고딕"/>
               </a:rPr>
-              <a:t>1일차 디노이저(37.42)와 2일차 Wiener(109.86)를 이어도 배포 baseline(25.01)에 진다. 역산이 노이즈를 +51.5 dB 증폭하기 때문이다.</a:t>
-            </a:r>
-          </a:p>
-        </p:txBody>
-      </p:sp>
-      <p:sp>
-        <p:nvSpPr>
-          <p:cNvPr id="14" name="Rounded Rectangle 13"/>
+              <a:t>왜 1일차 + 2일차가 안 되는가 · 선형의 천장</a:t>
+            </a:r>
+          </a:p>
+        </p:txBody>
+      </p:sp>
+      <p:sp>
+        <p:nvSpPr>
+          <p:cNvPr id="14" name="TextBox 13"/>
+          <p:cNvSpPr txBox="1"/>
+          <p:nvPr/>
+        </p:nvSpPr>
+        <p:spPr>
+          <a:xfrm>
+            <a:off x="9418320" y="2414016"/>
+            <a:ext cx="1737360" cy="365760"/>
+          </a:xfrm>
+          <a:prstGeom prst="rect">
+            <a:avLst/>
+          </a:prstGeom>
+          <a:noFill/>
+        </p:spPr>
+        <p:txBody>
+          <a:bodyPr wrap="square" anchor="t">
+            <a:spAutoFit/>
+          </a:bodyPr>
+          <a:lstStyle/>
+          <a:p>
+            <a:pPr algn="r">
+              <a:lnSpc>
+                <a:spcPct val="125000"/>
+              </a:lnSpc>
+            </a:pPr>
+            <a:r>
+              <a:rPr sz="1050" b="0">
+                <a:solidFill>
+                  <a:srgbClr val="0B6E5E"/>
+                </a:solidFill>
+                <a:latin typeface="Consolas"/>
+              </a:rPr>
+              <a:t>요구사항 3</a:t>
+            </a:r>
+          </a:p>
+        </p:txBody>
+      </p:sp>
+      <p:sp>
+        <p:nvSpPr>
+          <p:cNvPr id="15" name="Rounded Rectangle 14"/>
           <p:cNvSpPr/>
           <p:nvPr/>
         </p:nvSpPr>
         <p:spPr>
           <a:xfrm>
-            <a:off x="822960" y="3657600"/>
-            <a:ext cx="10515600" cy="960120"/>
+            <a:off x="822960" y="2916936"/>
+            <a:ext cx="10515600" cy="566928"/>
           </a:xfrm>
           <a:prstGeom prst="roundRect">
             <a:avLst>
@@ -10940,19 +11423,20 @@
           <a:lstStyle/>
           <a:p>
             <a:pPr algn="ctr"/>
-          </a:p>
-        </p:txBody>
-      </p:sp>
-      <p:sp>
-        <p:nvSpPr>
-          <p:cNvPr id="15" name="TextBox 14"/>
+            <a:endParaRPr/>
+          </a:p>
+        </p:txBody>
+      </p:sp>
+      <p:sp>
+        <p:nvSpPr>
+          <p:cNvPr id="16" name="TextBox 15"/>
           <p:cNvSpPr txBox="1"/>
           <p:nvPr/>
         </p:nvSpPr>
         <p:spPr>
           <a:xfrm>
-            <a:off x="1051560" y="3913632"/>
-            <a:ext cx="1005840" cy="365760"/>
+            <a:off x="1051560" y="3035808"/>
+            <a:ext cx="457200" cy="365760"/>
           </a:xfrm>
           <a:prstGeom prst="rect">
             <a:avLst/>
@@ -10971,27 +11455,27 @@
               </a:lnSpc>
             </a:pPr>
             <a:r>
-              <a:rPr sz="1200" b="1">
+              <a:rPr sz="1500" b="1">
                 <a:solidFill>
                   <a:srgbClr val="0B6E5E"/>
                 </a:solidFill>
                 <a:latin typeface="Consolas"/>
               </a:rPr>
-              <a:t>한계</a:t>
-            </a:r>
-          </a:p>
-        </p:txBody>
-      </p:sp>
-      <p:sp>
-        <p:nvSpPr>
-          <p:cNvPr id="16" name="TextBox 15"/>
+              <a:t>3</a:t>
+            </a:r>
+          </a:p>
+        </p:txBody>
+      </p:sp>
+      <p:sp>
+        <p:nvSpPr>
+          <p:cNvPr id="17" name="TextBox 16"/>
           <p:cNvSpPr txBox="1"/>
           <p:nvPr/>
         </p:nvSpPr>
         <p:spPr>
           <a:xfrm>
-            <a:off x="2103120" y="3767328"/>
-            <a:ext cx="9052560" cy="320040"/>
+            <a:off x="1645920" y="3044952"/>
+            <a:ext cx="2743200" cy="365760"/>
           </a:xfrm>
           <a:prstGeom prst="rect">
             <a:avLst/>
@@ -11010,27 +11494,27 @@
               </a:lnSpc>
             </a:pPr>
             <a:r>
-              <a:rPr sz="1400" b="1">
+              <a:rPr sz="1350" b="1">
                 <a:solidFill>
                   <a:srgbClr val="131A19"/>
                 </a:solidFill>
                 <a:latin typeface="맑은 고딕"/>
               </a:rPr>
-              <a:t>선형 방법의 천장은 19.80 dB</a:t>
-            </a:r>
-          </a:p>
-        </p:txBody>
-      </p:sp>
-      <p:sp>
-        <p:nvSpPr>
-          <p:cNvPr id="17" name="TextBox 16"/>
+              <a:t>설계 선택</a:t>
+            </a:r>
+          </a:p>
+        </p:txBody>
+      </p:sp>
+      <p:sp>
+        <p:nvSpPr>
+          <p:cNvPr id="18" name="TextBox 17"/>
           <p:cNvSpPr txBox="1"/>
           <p:nvPr/>
         </p:nvSpPr>
         <p:spPr>
           <a:xfrm>
-            <a:off x="2103120" y="4114800"/>
-            <a:ext cx="9052560" cy="457200"/>
+            <a:off x="4480560" y="3072384"/>
+            <a:ext cx="4937760" cy="365760"/>
           </a:xfrm>
           <a:prstGeom prst="rect">
             <a:avLst/>
@@ -11055,21 +11539,60 @@
                 </a:solidFill>
                 <a:latin typeface="맑은 고딕"/>
               </a:rPr>
-              <a:t>정답을 알고 만든 최고의 선형 필터(오라클 위너)조차 그렇다. 그 위는 비선형 사전지식의 몫이다.</a:t>
-            </a:r>
-          </a:p>
-        </p:txBody>
-      </p:sp>
-      <p:sp>
-        <p:nvSpPr>
-          <p:cNvPr id="18" name="Rounded Rectangle 17"/>
+              <a:t>왜 전개형인가 · σ 를 라벨 없이 읽는 법</a:t>
+            </a:r>
+          </a:p>
+        </p:txBody>
+      </p:sp>
+      <p:sp>
+        <p:nvSpPr>
+          <p:cNvPr id="19" name="TextBox 18"/>
+          <p:cNvSpPr txBox="1"/>
+          <p:nvPr/>
+        </p:nvSpPr>
+        <p:spPr>
+          <a:xfrm>
+            <a:off x="9418320" y="3072384"/>
+            <a:ext cx="1737360" cy="365760"/>
+          </a:xfrm>
+          <a:prstGeom prst="rect">
+            <a:avLst/>
+          </a:prstGeom>
+          <a:noFill/>
+        </p:spPr>
+        <p:txBody>
+          <a:bodyPr wrap="square" anchor="t">
+            <a:spAutoFit/>
+          </a:bodyPr>
+          <a:lstStyle/>
+          <a:p>
+            <a:pPr algn="r">
+              <a:lnSpc>
+                <a:spcPct val="125000"/>
+              </a:lnSpc>
+            </a:pPr>
+            <a:r>
+              <a:rPr sz="1050" b="0">
+                <a:solidFill>
+                  <a:srgbClr val="0B6E5E"/>
+                </a:solidFill>
+                <a:latin typeface="Consolas"/>
+              </a:rPr>
+              <a:t>요구사항 3</a:t>
+            </a:r>
+          </a:p>
+        </p:txBody>
+      </p:sp>
+      <p:sp>
+        <p:nvSpPr>
+          <p:cNvPr id="20" name="Rounded Rectangle 19"/>
           <p:cNvSpPr/>
           <p:nvPr/>
         </p:nvSpPr>
         <p:spPr>
           <a:xfrm>
-            <a:off x="822960" y="4709160"/>
-            <a:ext cx="10515600" cy="960120"/>
+            <a:off x="822960" y="3575304"/>
+            <a:ext cx="10515600" cy="566928"/>
           </a:xfrm>
           <a:prstGeom prst="roundRect">
             <a:avLst>
@@ -11105,19 +11628,20 @@
           <a:lstStyle/>
           <a:p>
             <a:pPr algn="ctr"/>
-          </a:p>
-        </p:txBody>
-      </p:sp>
-      <p:sp>
-        <p:nvSpPr>
-          <p:cNvPr id="19" name="TextBox 18"/>
+            <a:endParaRPr/>
+          </a:p>
+        </p:txBody>
+      </p:sp>
+      <p:sp>
+        <p:nvSpPr>
+          <p:cNvPr id="21" name="TextBox 20"/>
           <p:cNvSpPr txBox="1"/>
           <p:nvPr/>
         </p:nvSpPr>
         <p:spPr>
           <a:xfrm>
-            <a:off x="1051560" y="4965192"/>
-            <a:ext cx="1005840" cy="365760"/>
+            <a:off x="1051560" y="3694176"/>
+            <a:ext cx="457200" cy="365760"/>
           </a:xfrm>
           <a:prstGeom prst="rect">
             <a:avLst/>
@@ -11136,27 +11660,27 @@
               </a:lnSpc>
             </a:pPr>
             <a:r>
-              <a:rPr sz="1200" b="1">
+              <a:rPr sz="1500" b="1">
                 <a:solidFill>
                   <a:srgbClr val="0B6E5E"/>
                 </a:solidFill>
                 <a:latin typeface="Consolas"/>
               </a:rPr>
-              <a:t>답</a:t>
-            </a:r>
-          </a:p>
-        </p:txBody>
-      </p:sp>
-      <p:sp>
-        <p:nvSpPr>
-          <p:cNvPr id="20" name="TextBox 19"/>
+              <a:t>4</a:t>
+            </a:r>
+          </a:p>
+        </p:txBody>
+      </p:sp>
+      <p:sp>
+        <p:nvSpPr>
+          <p:cNvPr id="22" name="TextBox 21"/>
           <p:cNvSpPr txBox="1"/>
           <p:nvPr/>
         </p:nvSpPr>
         <p:spPr>
           <a:xfrm>
-            <a:off x="2103120" y="4818888"/>
-            <a:ext cx="9052560" cy="320040"/>
+            <a:off x="1645920" y="3703320"/>
+            <a:ext cx="2743200" cy="365760"/>
           </a:xfrm>
           <a:prstGeom prst="rect">
             <a:avLst/>
@@ -11175,27 +11699,27 @@
               </a:lnSpc>
             </a:pPr>
             <a:r>
-              <a:rPr sz="1400" b="1">
+              <a:rPr sz="1350" b="1">
                 <a:solidFill>
                   <a:srgbClr val="131A19"/>
                 </a:solidFill>
                 <a:latin typeface="맑은 고딕"/>
               </a:rPr>
-              <a:t>전개형 — 물리 제약과 학습된 사전지식을 번갈아</a:t>
-            </a:r>
-          </a:p>
-        </p:txBody>
-      </p:sp>
-      <p:sp>
-        <p:nvSpPr>
-          <p:cNvPr id="21" name="TextBox 20"/>
+              <a:t>복원 결과</a:t>
+            </a:r>
+          </a:p>
+        </p:txBody>
+      </p:sp>
+      <p:sp>
+        <p:nvSpPr>
+          <p:cNvPr id="23" name="TextBox 22"/>
           <p:cNvSpPr txBox="1"/>
           <p:nvPr/>
         </p:nvSpPr>
         <p:spPr>
           <a:xfrm>
-            <a:off x="2103120" y="5166360"/>
-            <a:ext cx="9052560" cy="457200"/>
+            <a:off x="4480560" y="3730752"/>
+            <a:ext cx="4937760" cy="365760"/>
           </a:xfrm>
           <a:prstGeom prst="rect">
             <a:avLst/>
@@ -11220,21 +11744,60 @@
                 </a:solidFill>
                 <a:latin typeface="맑은 고딕"/>
               </a:rPr>
-              <a:t>역산은 닫힌 해로 정확히 풀고, 네트워크는 역산이 포기한 주파수를 메우는 데만 용량을 쓴다. σ 는 측정치에서 읽어 장마다 다른 노이즈 세기에 맞춘다.</a:t>
-            </a:r>
-          </a:p>
-        </p:txBody>
-      </p:sp>
-      <p:sp>
-        <p:nvSpPr>
-          <p:cNvPr id="22" name="Rounded Rectangle 21"/>
+              <a:t>before / after / difference / GT · 노이즈별 격자</a:t>
+            </a:r>
+          </a:p>
+        </p:txBody>
+      </p:sp>
+      <p:sp>
+        <p:nvSpPr>
+          <p:cNvPr id="24" name="TextBox 23"/>
+          <p:cNvSpPr txBox="1"/>
+          <p:nvPr/>
+        </p:nvSpPr>
+        <p:spPr>
+          <a:xfrm>
+            <a:off x="9418320" y="3730752"/>
+            <a:ext cx="1737360" cy="365760"/>
+          </a:xfrm>
+          <a:prstGeom prst="rect">
+            <a:avLst/>
+          </a:prstGeom>
+          <a:noFill/>
+        </p:spPr>
+        <p:txBody>
+          <a:bodyPr wrap="square" anchor="t">
+            <a:spAutoFit/>
+          </a:bodyPr>
+          <a:lstStyle/>
+          <a:p>
+            <a:pPr algn="r">
+              <a:lnSpc>
+                <a:spcPct val="125000"/>
+              </a:lnSpc>
+            </a:pPr>
+            <a:r>
+              <a:rPr sz="1050" b="0">
+                <a:solidFill>
+                  <a:srgbClr val="0B6E5E"/>
+                </a:solidFill>
+                <a:latin typeface="Consolas"/>
+              </a:rPr>
+              <a:t>요구사항 2</a:t>
+            </a:r>
+          </a:p>
+        </p:txBody>
+      </p:sp>
+      <p:sp>
+        <p:nvSpPr>
+          <p:cNvPr id="25" name="Rounded Rectangle 24"/>
           <p:cNvSpPr/>
           <p:nvPr/>
         </p:nvSpPr>
         <p:spPr>
           <a:xfrm>
-            <a:off x="822960" y="5532120"/>
-            <a:ext cx="10515600" cy="777240"/>
+            <a:off x="822960" y="4233672"/>
+            <a:ext cx="10515600" cy="566928"/>
           </a:xfrm>
           <a:prstGeom prst="roundRect">
             <a:avLst>
@@ -11242,11 +11805,11 @@
             </a:avLst>
           </a:prstGeom>
           <a:solidFill>
-            <a:srgbClr val="DCEDE8"/>
+            <a:srgbClr val="F3F6F5"/>
           </a:solidFill>
           <a:ln w="9525">
             <a:solidFill>
-              <a:srgbClr val="0B6E5E"/>
+              <a:srgbClr val="DCE3E0"/>
             </a:solidFill>
           </a:ln>
           <a:effectLst/>
@@ -11270,19 +11833,20 @@
           <a:lstStyle/>
           <a:p>
             <a:pPr algn="ctr"/>
-          </a:p>
-        </p:txBody>
-      </p:sp>
-      <p:sp>
-        <p:nvSpPr>
-          <p:cNvPr id="23" name="TextBox 22"/>
+            <a:endParaRPr/>
+          </a:p>
+        </p:txBody>
+      </p:sp>
+      <p:sp>
+        <p:nvSpPr>
+          <p:cNvPr id="26" name="TextBox 25"/>
           <p:cNvSpPr txBox="1"/>
           <p:nvPr/>
         </p:nvSpPr>
         <p:spPr>
           <a:xfrm>
-            <a:off x="1051560" y="5687568"/>
-            <a:ext cx="10058400" cy="457200"/>
+            <a:off x="1051560" y="4352544"/>
+            <a:ext cx="457200" cy="365760"/>
           </a:xfrm>
           <a:prstGeom prst="rect">
             <a:avLst/>
@@ -11301,13 +11865,501 @@
               </a:lnSpc>
             </a:pPr>
             <a:r>
-              <a:rPr sz="1300" b="1">
+              <a:rPr sz="1500" b="1">
+                <a:solidFill>
+                  <a:srgbClr val="0B6E5E"/>
+                </a:solidFill>
+                <a:latin typeface="Consolas"/>
+              </a:rPr>
+              <a:t>5</a:t>
+            </a:r>
+          </a:p>
+        </p:txBody>
+      </p:sp>
+      <p:sp>
+        <p:nvSpPr>
+          <p:cNvPr id="27" name="TextBox 26"/>
+          <p:cNvSpPr txBox="1"/>
+          <p:nvPr/>
+        </p:nvSpPr>
+        <p:spPr>
+          <a:xfrm>
+            <a:off x="1645920" y="4361688"/>
+            <a:ext cx="2743200" cy="365760"/>
+          </a:xfrm>
+          <a:prstGeom prst="rect">
+            <a:avLst/>
+          </a:prstGeom>
+          <a:noFill/>
+        </p:spPr>
+        <p:txBody>
+          <a:bodyPr wrap="square" anchor="t">
+            <a:spAutoFit/>
+          </a:bodyPr>
+          <a:lstStyle/>
+          <a:p>
+            <a:pPr algn="l">
+              <a:lnSpc>
+                <a:spcPct val="125000"/>
+              </a:lnSpc>
+            </a:pPr>
+            <a:r>
+              <a:rPr sz="1350" b="1">
                 <a:solidFill>
                   <a:srgbClr val="131A19"/>
                 </a:solidFill>
                 <a:latin typeface="맑은 고딕"/>
               </a:rPr>
-              <a:t>결과   29.25 dB / 0.8777   ·   배포 baseline 25.01 / 0.8149 대비 +4.24 dB · +0.0628   ·   통과 기준 26 / 0.83</a:t>
+              <a:t>결과 분석</a:t>
+            </a:r>
+          </a:p>
+        </p:txBody>
+      </p:sp>
+      <p:sp>
+        <p:nvSpPr>
+          <p:cNvPr id="28" name="TextBox 27"/>
+          <p:cNvSpPr txBox="1"/>
+          <p:nvPr/>
+        </p:nvSpPr>
+        <p:spPr>
+          <a:xfrm>
+            <a:off x="4480560" y="4389120"/>
+            <a:ext cx="4937760" cy="365760"/>
+          </a:xfrm>
+          <a:prstGeom prst="rect">
+            <a:avLst/>
+          </a:prstGeom>
+          <a:noFill/>
+        </p:spPr>
+        <p:txBody>
+          <a:bodyPr wrap="square" anchor="t">
+            <a:spAutoFit/>
+          </a:bodyPr>
+          <a:lstStyle/>
+          <a:p>
+            <a:pPr algn="l">
+              <a:lnSpc>
+                <a:spcPct val="125000"/>
+              </a:lnSpc>
+            </a:pPr>
+            <a:r>
+              <a:rPr sz="1150" b="0">
+                <a:solidFill>
+                  <a:srgbClr val="66756F"/>
+                </a:solidFill>
+                <a:latin typeface="맑은 고딕"/>
+              </a:rPr>
+              <a:t>어떤 노이즈·어떤 이미지에 취약한가 · σ ablation</a:t>
+            </a:r>
+          </a:p>
+        </p:txBody>
+      </p:sp>
+      <p:sp>
+        <p:nvSpPr>
+          <p:cNvPr id="29" name="TextBox 28"/>
+          <p:cNvSpPr txBox="1"/>
+          <p:nvPr/>
+        </p:nvSpPr>
+        <p:spPr>
+          <a:xfrm>
+            <a:off x="9418320" y="4389120"/>
+            <a:ext cx="1737360" cy="365760"/>
+          </a:xfrm>
+          <a:prstGeom prst="rect">
+            <a:avLst/>
+          </a:prstGeom>
+          <a:noFill/>
+        </p:spPr>
+        <p:txBody>
+          <a:bodyPr wrap="square" anchor="t">
+            <a:spAutoFit/>
+          </a:bodyPr>
+          <a:lstStyle/>
+          <a:p>
+            <a:pPr algn="r">
+              <a:lnSpc>
+                <a:spcPct val="125000"/>
+              </a:lnSpc>
+            </a:pPr>
+            <a:r>
+              <a:rPr sz="1050" b="0">
+                <a:solidFill>
+                  <a:srgbClr val="0B6E5E"/>
+                </a:solidFill>
+                <a:latin typeface="Consolas"/>
+              </a:rPr>
+              <a:t>tips</a:t>
+            </a:r>
+          </a:p>
+        </p:txBody>
+      </p:sp>
+      <p:sp>
+        <p:nvSpPr>
+          <p:cNvPr id="30" name="Rounded Rectangle 29"/>
+          <p:cNvSpPr/>
+          <p:nvPr/>
+        </p:nvSpPr>
+        <p:spPr>
+          <a:xfrm>
+            <a:off x="822960" y="4892040"/>
+            <a:ext cx="10515600" cy="566928"/>
+          </a:xfrm>
+          <a:prstGeom prst="roundRect">
+            <a:avLst>
+              <a:gd name="adj" fmla="val 4000"/>
+            </a:avLst>
+          </a:prstGeom>
+          <a:solidFill>
+            <a:srgbClr val="F3F6F5"/>
+          </a:solidFill>
+          <a:ln w="9525">
+            <a:solidFill>
+              <a:srgbClr val="DCE3E0"/>
+            </a:solidFill>
+          </a:ln>
+          <a:effectLst/>
+        </p:spPr>
+        <p:style>
+          <a:lnRef idx="1">
+            <a:schemeClr val="accent1"/>
+          </a:lnRef>
+          <a:fillRef idx="3">
+            <a:schemeClr val="accent1"/>
+          </a:fillRef>
+          <a:effectRef idx="2">
+            <a:schemeClr val="accent1"/>
+          </a:effectRef>
+          <a:fontRef idx="minor">
+            <a:schemeClr val="lt1"/>
+          </a:fontRef>
+        </p:style>
+        <p:txBody>
+          <a:bodyPr rtlCol="0" anchor="ctr"/>
+          <a:lstStyle/>
+          <a:p>
+            <a:pPr algn="ctr"/>
+            <a:endParaRPr/>
+          </a:p>
+        </p:txBody>
+      </p:sp>
+      <p:sp>
+        <p:nvSpPr>
+          <p:cNvPr id="31" name="TextBox 30"/>
+          <p:cNvSpPr txBox="1"/>
+          <p:nvPr/>
+        </p:nvSpPr>
+        <p:spPr>
+          <a:xfrm>
+            <a:off x="1051560" y="5010912"/>
+            <a:ext cx="457200" cy="365760"/>
+          </a:xfrm>
+          <a:prstGeom prst="rect">
+            <a:avLst/>
+          </a:prstGeom>
+          <a:noFill/>
+        </p:spPr>
+        <p:txBody>
+          <a:bodyPr wrap="square" anchor="t">
+            <a:spAutoFit/>
+          </a:bodyPr>
+          <a:lstStyle/>
+          <a:p>
+            <a:pPr algn="l">
+              <a:lnSpc>
+                <a:spcPct val="125000"/>
+              </a:lnSpc>
+            </a:pPr>
+            <a:r>
+              <a:rPr sz="1500" b="1">
+                <a:solidFill>
+                  <a:srgbClr val="0B6E5E"/>
+                </a:solidFill>
+                <a:latin typeface="Consolas"/>
+              </a:rPr>
+              <a:t>6</a:t>
+            </a:r>
+          </a:p>
+        </p:txBody>
+      </p:sp>
+      <p:sp>
+        <p:nvSpPr>
+          <p:cNvPr id="32" name="TextBox 31"/>
+          <p:cNvSpPr txBox="1"/>
+          <p:nvPr/>
+        </p:nvSpPr>
+        <p:spPr>
+          <a:xfrm>
+            <a:off x="1645920" y="5020056"/>
+            <a:ext cx="2743200" cy="365760"/>
+          </a:xfrm>
+          <a:prstGeom prst="rect">
+            <a:avLst/>
+          </a:prstGeom>
+          <a:noFill/>
+        </p:spPr>
+        <p:txBody>
+          <a:bodyPr wrap="square" anchor="t">
+            <a:spAutoFit/>
+          </a:bodyPr>
+          <a:lstStyle/>
+          <a:p>
+            <a:pPr algn="l">
+              <a:lnSpc>
+                <a:spcPct val="125000"/>
+              </a:lnSpc>
+            </a:pPr>
+            <a:r>
+              <a:rPr sz="1350" b="1">
+                <a:solidFill>
+                  <a:srgbClr val="131A19"/>
+                </a:solidFill>
+                <a:latin typeface="맑은 고딕"/>
+              </a:rPr>
+              <a:t>label-free</a:t>
+            </a:r>
+          </a:p>
+        </p:txBody>
+      </p:sp>
+      <p:sp>
+        <p:nvSpPr>
+          <p:cNvPr id="33" name="TextBox 32"/>
+          <p:cNvSpPr txBox="1"/>
+          <p:nvPr/>
+        </p:nvSpPr>
+        <p:spPr>
+          <a:xfrm>
+            <a:off x="4480560" y="5047488"/>
+            <a:ext cx="4937760" cy="365760"/>
+          </a:xfrm>
+          <a:prstGeom prst="rect">
+            <a:avLst/>
+          </a:prstGeom>
+          <a:noFill/>
+        </p:spPr>
+        <p:txBody>
+          <a:bodyPr wrap="square" anchor="t">
+            <a:spAutoFit/>
+          </a:bodyPr>
+          <a:lstStyle/>
+          <a:p>
+            <a:pPr algn="l">
+              <a:lnSpc>
+                <a:spcPct val="125000"/>
+              </a:lnSpc>
+            </a:pPr>
+            <a:r>
+              <a:rPr sz="1150" b="0">
+                <a:solidFill>
+                  <a:srgbClr val="66756F"/>
+                </a:solidFill>
+                <a:latin typeface="맑은 고딕"/>
+              </a:rPr>
+              <a:t>정답을 한 장도 쓰지 않고 푼다</a:t>
+            </a:r>
+          </a:p>
+        </p:txBody>
+      </p:sp>
+      <p:sp>
+        <p:nvSpPr>
+          <p:cNvPr id="34" name="TextBox 33"/>
+          <p:cNvSpPr txBox="1"/>
+          <p:nvPr/>
+        </p:nvSpPr>
+        <p:spPr>
+          <a:xfrm>
+            <a:off x="9418320" y="5047488"/>
+            <a:ext cx="1737360" cy="365760"/>
+          </a:xfrm>
+          <a:prstGeom prst="rect">
+            <a:avLst/>
+          </a:prstGeom>
+          <a:noFill/>
+        </p:spPr>
+        <p:txBody>
+          <a:bodyPr wrap="square" anchor="t">
+            <a:spAutoFit/>
+          </a:bodyPr>
+          <a:lstStyle/>
+          <a:p>
+            <a:pPr algn="r">
+              <a:lnSpc>
+                <a:spcPct val="125000"/>
+              </a:lnSpc>
+            </a:pPr>
+            <a:r>
+              <a:rPr sz="1050" b="0">
+                <a:solidFill>
+                  <a:srgbClr val="0B6E5E"/>
+                </a:solidFill>
+                <a:latin typeface="Consolas"/>
+              </a:rPr>
+              <a:t>요구사항 4 · 보너스</a:t>
+            </a:r>
+          </a:p>
+        </p:txBody>
+      </p:sp>
+      <p:sp>
+        <p:nvSpPr>
+          <p:cNvPr id="35" name="Rounded Rectangle 34"/>
+          <p:cNvSpPr/>
+          <p:nvPr/>
+        </p:nvSpPr>
+        <p:spPr>
+          <a:xfrm>
+            <a:off x="822960" y="5550408"/>
+            <a:ext cx="10515600" cy="566928"/>
+          </a:xfrm>
+          <a:prstGeom prst="roundRect">
+            <a:avLst>
+              <a:gd name="adj" fmla="val 4000"/>
+            </a:avLst>
+          </a:prstGeom>
+          <a:solidFill>
+            <a:srgbClr val="F3F6F5"/>
+          </a:solidFill>
+          <a:ln w="9525">
+            <a:solidFill>
+              <a:srgbClr val="DCE3E0"/>
+            </a:solidFill>
+          </a:ln>
+          <a:effectLst/>
+        </p:spPr>
+        <p:style>
+          <a:lnRef idx="1">
+            <a:schemeClr val="accent1"/>
+          </a:lnRef>
+          <a:fillRef idx="3">
+            <a:schemeClr val="accent1"/>
+          </a:fillRef>
+          <a:effectRef idx="2">
+            <a:schemeClr val="accent1"/>
+          </a:effectRef>
+          <a:fontRef idx="minor">
+            <a:schemeClr val="lt1"/>
+          </a:fontRef>
+        </p:style>
+        <p:txBody>
+          <a:bodyPr rtlCol="0" anchor="ctr"/>
+          <a:lstStyle/>
+          <a:p>
+            <a:pPr algn="ctr"/>
+            <a:endParaRPr/>
+          </a:p>
+        </p:txBody>
+      </p:sp>
+      <p:sp>
+        <p:nvSpPr>
+          <p:cNvPr id="36" name="TextBox 35"/>
+          <p:cNvSpPr txBox="1"/>
+          <p:nvPr/>
+        </p:nvSpPr>
+        <p:spPr>
+          <a:xfrm>
+            <a:off x="1051560" y="5669280"/>
+            <a:ext cx="457200" cy="365760"/>
+          </a:xfrm>
+          <a:prstGeom prst="rect">
+            <a:avLst/>
+          </a:prstGeom>
+          <a:noFill/>
+        </p:spPr>
+        <p:txBody>
+          <a:bodyPr wrap="square" anchor="t">
+            <a:spAutoFit/>
+          </a:bodyPr>
+          <a:lstStyle/>
+          <a:p>
+            <a:pPr algn="l">
+              <a:lnSpc>
+                <a:spcPct val="125000"/>
+              </a:lnSpc>
+            </a:pPr>
+            <a:r>
+              <a:rPr sz="1500" b="1">
+                <a:solidFill>
+                  <a:srgbClr val="0B6E5E"/>
+                </a:solidFill>
+                <a:latin typeface="Consolas"/>
+              </a:rPr>
+              <a:t>7</a:t>
+            </a:r>
+          </a:p>
+        </p:txBody>
+      </p:sp>
+      <p:sp>
+        <p:nvSpPr>
+          <p:cNvPr id="37" name="TextBox 36"/>
+          <p:cNvSpPr txBox="1"/>
+          <p:nvPr/>
+        </p:nvSpPr>
+        <p:spPr>
+          <a:xfrm>
+            <a:off x="1645920" y="5678424"/>
+            <a:ext cx="2743200" cy="365760"/>
+          </a:xfrm>
+          <a:prstGeom prst="rect">
+            <a:avLst/>
+          </a:prstGeom>
+          <a:noFill/>
+        </p:spPr>
+        <p:txBody>
+          <a:bodyPr wrap="square" anchor="t">
+            <a:spAutoFit/>
+          </a:bodyPr>
+          <a:lstStyle/>
+          <a:p>
+            <a:pPr algn="l">
+              <a:lnSpc>
+                <a:spcPct val="125000"/>
+              </a:lnSpc>
+            </a:pPr>
+            <a:r>
+              <a:rPr sz="1350" b="1">
+                <a:solidFill>
+                  <a:srgbClr val="131A19"/>
+                </a:solidFill>
+                <a:latin typeface="맑은 고딕"/>
+              </a:rPr>
+              <a:t>시도별 요약</a:t>
+            </a:r>
+          </a:p>
+        </p:txBody>
+      </p:sp>
+      <p:sp>
+        <p:nvSpPr>
+          <p:cNvPr id="38" name="TextBox 37"/>
+          <p:cNvSpPr txBox="1"/>
+          <p:nvPr/>
+        </p:nvSpPr>
+        <p:spPr>
+          <a:xfrm>
+            <a:off x="4480560" y="5705856"/>
+            <a:ext cx="4937760" cy="365760"/>
+          </a:xfrm>
+          <a:prstGeom prst="rect">
+            <a:avLst/>
+          </a:prstGeom>
+          <a:noFill/>
+        </p:spPr>
+        <p:txBody>
+          <a:bodyPr wrap="square" anchor="t">
+            <a:spAutoFit/>
+          </a:bodyPr>
+          <a:lstStyle/>
+          <a:p>
+            <a:pPr algn="l">
+              <a:lnSpc>
+                <a:spcPct val="125000"/>
+              </a:lnSpc>
+            </a:pPr>
+            <a:r>
+              <a:rPr sz="1150" b="0">
+                <a:solidFill>
+                  <a:srgbClr val="66756F"/>
+                </a:solidFill>
+                <a:latin typeface="맑은 고딕"/>
+              </a:rPr>
+              <a:t>무엇을 해봤고 무엇을 배웠나 · 검증 규칙</a:t>
             </a:r>
           </a:p>
         </p:txBody>
@@ -11321,7 +12373,7 @@
 </file>
 
 <file path=ppt/slides/slide3.xml><?xml version="1.0" encoding="utf-8"?>
-<p:sld xmlns:a="http://schemas.openxmlformats.org/drawingml/2006/main" xmlns:p="http://schemas.openxmlformats.org/presentationml/2006/main" xmlns:r="http://schemas.openxmlformats.org/officeDocument/2006/relationships">
+<p:sld xmlns:a="http://schemas.openxmlformats.org/drawingml/2006/main" xmlns:r="http://schemas.openxmlformats.org/officeDocument/2006/relationships" xmlns:p="http://schemas.openxmlformats.org/presentationml/2006/main">
   <p:cSld>
     <p:bg>
       <p:bgPr>
@@ -11337,7 +12389,14 @@
         <p:cNvGrpSpPr/>
         <p:nvPr/>
       </p:nvGrpSpPr>
-      <p:grpSpPr/>
+      <p:grpSpPr>
+        <a:xfrm>
+          <a:off x="0" y="0"/>
+          <a:ext cx="0" cy="0"/>
+          <a:chOff x="0" y="0"/>
+          <a:chExt cx="0" cy="0"/>
+        </a:xfrm>
+      </p:grpSpPr>
       <p:sp>
         <p:nvSpPr>
           <p:cNvPr id="2" name="TextBox 1"/>
@@ -11372,7 +12431,7 @@
                 </a:solidFill>
                 <a:latin typeface="Consolas"/>
               </a:rPr>
-              <a:t>Contents</a:t>
+              <a:t>Summary</a:t>
             </a:r>
           </a:p>
         </p:txBody>
@@ -11411,20 +12470,74 @@
                 </a:solidFill>
                 <a:latin typeface="맑은 고딕"/>
               </a:rPr>
-              <a:t>목차</a:t>
-            </a:r>
-          </a:p>
-        </p:txBody>
-      </p:sp>
-      <p:sp>
-        <p:nvSpPr>
-          <p:cNvPr id="4" name="Rectangle 3"/>
+              <a:t>요약</a:t>
+            </a:r>
+          </a:p>
+        </p:txBody>
+      </p:sp>
+      <p:sp>
+        <p:nvSpPr>
+          <p:cNvPr id="4" name="TextBox 3"/>
+          <p:cNvSpPr txBox="1"/>
+          <p:nvPr/>
+        </p:nvSpPr>
+        <p:spPr>
+          <a:xfrm>
+            <a:off x="640080" y="1371600"/>
+            <a:ext cx="10972800" cy="365760"/>
+          </a:xfrm>
+          <a:prstGeom prst="rect">
+            <a:avLst/>
+          </a:prstGeom>
+          <a:noFill/>
+        </p:spPr>
+        <p:txBody>
+          <a:bodyPr wrap="square" anchor="t">
+            <a:spAutoFit/>
+          </a:bodyPr>
+          <a:lstStyle/>
+          <a:p>
+            <a:pPr algn="l">
+              <a:lnSpc>
+                <a:spcPct val="125000"/>
+              </a:lnSpc>
+            </a:pPr>
+            <a:r>
+              <a:rPr sz="1400" b="0" dirty="0">
+                <a:solidFill>
+                  <a:srgbClr val="66756F"/>
+                </a:solidFill>
+                <a:latin typeface="맑은 고딕"/>
+              </a:rPr>
+              <a:t>한 </a:t>
+            </a:r>
+            <a:r>
+              <a:rPr sz="1400" b="0" dirty="0" err="1">
+                <a:solidFill>
+                  <a:srgbClr val="66756F"/>
+                </a:solidFill>
+                <a:latin typeface="맑은 고딕"/>
+              </a:rPr>
+              <a:t>장으로</a:t>
+            </a:r>
+            <a:endParaRPr sz="1400" b="0" dirty="0">
+              <a:solidFill>
+                <a:srgbClr val="66756F"/>
+              </a:solidFill>
+              <a:latin typeface="맑은 고딕"/>
+            </a:endParaRPr>
+          </a:p>
+        </p:txBody>
+      </p:sp>
+      <p:sp>
+        <p:nvSpPr>
+          <p:cNvPr id="5" name="Rectangle 4"/>
           <p:cNvSpPr/>
           <p:nvPr/>
         </p:nvSpPr>
         <p:spPr>
           <a:xfrm>
-            <a:off x="640080" y="1417320"/>
+            <a:off x="640080" y="1874520"/>
             <a:ext cx="10908792" cy="15240"/>
           </a:xfrm>
           <a:prstGeom prst="rect">
@@ -11457,19 +12570,20 @@
           <a:lstStyle/>
           <a:p>
             <a:pPr algn="ctr"/>
-          </a:p>
-        </p:txBody>
-      </p:sp>
-      <p:sp>
-        <p:nvSpPr>
-          <p:cNvPr id="5" name="Rounded Rectangle 4"/>
+            <a:endParaRPr/>
+          </a:p>
+        </p:txBody>
+      </p:sp>
+      <p:sp>
+        <p:nvSpPr>
+          <p:cNvPr id="6" name="Rounded Rectangle 5"/>
           <p:cNvSpPr/>
           <p:nvPr/>
         </p:nvSpPr>
         <p:spPr>
           <a:xfrm>
-            <a:off x="822960" y="1600200"/>
-            <a:ext cx="10515600" cy="566928"/>
+            <a:off x="822960" y="1554480"/>
+            <a:ext cx="10515600" cy="960120"/>
           </a:xfrm>
           <a:prstGeom prst="roundRect">
             <a:avLst>
@@ -11505,19 +12619,20 @@
           <a:lstStyle/>
           <a:p>
             <a:pPr algn="ctr"/>
-          </a:p>
-        </p:txBody>
-      </p:sp>
-      <p:sp>
-        <p:nvSpPr>
-          <p:cNvPr id="6" name="TextBox 5"/>
+            <a:endParaRPr/>
+          </a:p>
+        </p:txBody>
+      </p:sp>
+      <p:sp>
+        <p:nvSpPr>
+          <p:cNvPr id="7" name="TextBox 6"/>
           <p:cNvSpPr txBox="1"/>
           <p:nvPr/>
         </p:nvSpPr>
         <p:spPr>
           <a:xfrm>
-            <a:off x="1051560" y="1719072"/>
-            <a:ext cx="457200" cy="365760"/>
+            <a:off x="1051560" y="1810512"/>
+            <a:ext cx="1005840" cy="365760"/>
           </a:xfrm>
           <a:prstGeom prst="rect">
             <a:avLst/>
@@ -11536,27 +12651,27 @@
               </a:lnSpc>
             </a:pPr>
             <a:r>
-              <a:rPr sz="1500" b="1">
+              <a:rPr sz="1200" b="1">
                 <a:solidFill>
                   <a:srgbClr val="0B6E5E"/>
                 </a:solidFill>
                 <a:latin typeface="Consolas"/>
               </a:rPr>
-              <a:t>1</a:t>
-            </a:r>
-          </a:p>
-        </p:txBody>
-      </p:sp>
-      <p:sp>
-        <p:nvSpPr>
-          <p:cNvPr id="7" name="TextBox 6"/>
+              <a:t>문제</a:t>
+            </a:r>
+          </a:p>
+        </p:txBody>
+      </p:sp>
+      <p:sp>
+        <p:nvSpPr>
+          <p:cNvPr id="8" name="TextBox 7"/>
           <p:cNvSpPr txBox="1"/>
           <p:nvPr/>
         </p:nvSpPr>
         <p:spPr>
           <a:xfrm>
-            <a:off x="1645920" y="1728216"/>
-            <a:ext cx="2743200" cy="365760"/>
+            <a:off x="2103120" y="1664208"/>
+            <a:ext cx="9052560" cy="320040"/>
           </a:xfrm>
           <a:prstGeom prst="rect">
             <a:avLst/>
@@ -11575,27 +12690,27 @@
               </a:lnSpc>
             </a:pPr>
             <a:r>
-              <a:rPr sz="1350" b="1">
+              <a:rPr sz="1400" b="1">
                 <a:solidFill>
                   <a:srgbClr val="131A19"/>
                 </a:solidFill>
                 <a:latin typeface="맑은 고딕"/>
               </a:rPr>
-              <a:t>파이프라인</a:t>
-            </a:r>
-          </a:p>
-        </p:txBody>
-      </p:sp>
-      <p:sp>
-        <p:nvSpPr>
-          <p:cNvPr id="8" name="TextBox 7"/>
+              <a:t>흐림과 노이즈가 겹쳤다  g = h * f + n</a:t>
+            </a:r>
+          </a:p>
+        </p:txBody>
+      </p:sp>
+      <p:sp>
+        <p:nvSpPr>
+          <p:cNvPr id="9" name="TextBox 8"/>
           <p:cNvSpPr txBox="1"/>
           <p:nvPr/>
         </p:nvSpPr>
         <p:spPr>
           <a:xfrm>
-            <a:off x="4480560" y="1755648"/>
-            <a:ext cx="4937760" cy="365760"/>
+            <a:off x="2103120" y="2011680"/>
+            <a:ext cx="9052560" cy="457200"/>
           </a:xfrm>
           <a:prstGeom prst="rect">
             <a:avLst/>
@@ -11620,46 +12735,7 @@
                 </a:solidFill>
                 <a:latin typeface="맑은 고딕"/>
               </a:rPr>
-              <a:t>무엇을 만들었나</a:t>
-            </a:r>
-          </a:p>
-        </p:txBody>
-      </p:sp>
-      <p:sp>
-        <p:nvSpPr>
-          <p:cNvPr id="9" name="TextBox 8"/>
-          <p:cNvSpPr txBox="1"/>
-          <p:nvPr/>
-        </p:nvSpPr>
-        <p:spPr>
-          <a:xfrm>
-            <a:off x="9418320" y="1755648"/>
-            <a:ext cx="1737360" cy="365760"/>
-          </a:xfrm>
-          <a:prstGeom prst="rect">
-            <a:avLst/>
-          </a:prstGeom>
-          <a:noFill/>
-        </p:spPr>
-        <p:txBody>
-          <a:bodyPr wrap="square" anchor="t">
-            <a:spAutoFit/>
-          </a:bodyPr>
-          <a:lstStyle/>
-          <a:p>
-            <a:pPr algn="r">
-              <a:lnSpc>
-                <a:spcPct val="125000"/>
-              </a:lnSpc>
-            </a:pPr>
-            <a:r>
-              <a:rPr sz="1050" b="0">
-                <a:solidFill>
-                  <a:srgbClr val="0B6E5E"/>
-                </a:solidFill>
-                <a:latin typeface="Consolas"/>
-              </a:rPr>
-              <a:t>요구사항 1</a:t>
+              <a:t>1일차는 노이즈만, 2일차는 흐림만이었다. 3일차는 둘이 겹쳐 각자의 답이 통하지 않는다.</a:t>
             </a:r>
           </a:p>
         </p:txBody>
@@ -11672,8 +12748,8 @@
         </p:nvSpPr>
         <p:spPr>
           <a:xfrm>
-            <a:off x="822960" y="2258568"/>
-            <a:ext cx="10515600" cy="566928"/>
+            <a:off x="822960" y="2606040"/>
+            <a:ext cx="10515600" cy="960120"/>
           </a:xfrm>
           <a:prstGeom prst="roundRect">
             <a:avLst>
@@ -11709,6 +12785,7 @@
           <a:lstStyle/>
           <a:p>
             <a:pPr algn="ctr"/>
+            <a:endParaRPr/>
           </a:p>
         </p:txBody>
       </p:sp>
@@ -11720,8 +12797,8 @@
         </p:nvSpPr>
         <p:spPr>
           <a:xfrm>
-            <a:off x="1051560" y="2377440"/>
-            <a:ext cx="457200" cy="365760"/>
+            <a:off x="1051560" y="2862072"/>
+            <a:ext cx="1005840" cy="365760"/>
           </a:xfrm>
           <a:prstGeom prst="rect">
             <a:avLst/>
@@ -11740,13 +12817,13 @@
               </a:lnSpc>
             </a:pPr>
             <a:r>
-              <a:rPr sz="1500" b="1">
+              <a:rPr sz="1200" b="1">
                 <a:solidFill>
                   <a:srgbClr val="0B6E5E"/>
                 </a:solidFill>
                 <a:latin typeface="Consolas"/>
               </a:rPr>
-              <a:t>2</a:t>
+              <a:t>발견</a:t>
             </a:r>
           </a:p>
         </p:txBody>
@@ -11759,8 +12836,8 @@
         </p:nvSpPr>
         <p:spPr>
           <a:xfrm>
-            <a:off x="1645920" y="2386584"/>
-            <a:ext cx="2743200" cy="365760"/>
+            <a:off x="2103120" y="2715768"/>
+            <a:ext cx="9052560" cy="320040"/>
           </a:xfrm>
           <a:prstGeom prst="rect">
             <a:avLst/>
@@ -11779,13 +12856,13 @@
               </a:lnSpc>
             </a:pPr>
             <a:r>
-              <a:rPr sz="1350" b="1">
+              <a:rPr sz="1400" b="1">
                 <a:solidFill>
                   <a:srgbClr val="131A19"/>
                 </a:solidFill>
                 <a:latin typeface="맑은 고딕"/>
               </a:rPr>
-              <a:t>문제와 근거</a:t>
+              <a:t>각자 최고인 도구를 이어 붙이면 진다 — 21.06 dB</a:t>
             </a:r>
           </a:p>
         </p:txBody>
@@ -11798,8 +12875,8 @@
         </p:nvSpPr>
         <p:spPr>
           <a:xfrm>
-            <a:off x="4480560" y="2414016"/>
-            <a:ext cx="4937760" cy="365760"/>
+            <a:off x="2103120" y="3063240"/>
+            <a:ext cx="9052560" cy="457200"/>
           </a:xfrm>
           <a:prstGeom prst="rect">
             <a:avLst/>
@@ -11824,60 +12901,21 @@
                 </a:solidFill>
                 <a:latin typeface="맑은 고딕"/>
               </a:rPr>
-              <a:t>왜 1일차 + 2일차가 안 되는가 · 선형의 천장</a:t>
-            </a:r>
-          </a:p>
-        </p:txBody>
-      </p:sp>
-      <p:sp>
-        <p:nvSpPr>
-          <p:cNvPr id="14" name="TextBox 13"/>
-          <p:cNvSpPr txBox="1"/>
-          <p:nvPr/>
-        </p:nvSpPr>
-        <p:spPr>
-          <a:xfrm>
-            <a:off x="9418320" y="2414016"/>
-            <a:ext cx="1737360" cy="365760"/>
-          </a:xfrm>
-          <a:prstGeom prst="rect">
-            <a:avLst/>
-          </a:prstGeom>
-          <a:noFill/>
-        </p:spPr>
-        <p:txBody>
-          <a:bodyPr wrap="square" anchor="t">
-            <a:spAutoFit/>
-          </a:bodyPr>
-          <a:lstStyle/>
-          <a:p>
-            <a:pPr algn="r">
-              <a:lnSpc>
-                <a:spcPct val="125000"/>
-              </a:lnSpc>
-            </a:pPr>
-            <a:r>
-              <a:rPr sz="1050" b="0">
-                <a:solidFill>
-                  <a:srgbClr val="0B6E5E"/>
-                </a:solidFill>
-                <a:latin typeface="Consolas"/>
-              </a:rPr>
-              <a:t>요구사항 3</a:t>
-            </a:r>
-          </a:p>
-        </p:txBody>
-      </p:sp>
-      <p:sp>
-        <p:nvSpPr>
-          <p:cNvPr id="15" name="Rounded Rectangle 14"/>
+              <a:t>1일차 디노이저(37.42)와 2일차 Wiener(109.86)를 이어도 배포 baseline(25.01)에 진다. 역산이 노이즈를 +51.5 dB 증폭하기 때문이다.</a:t>
+            </a:r>
+          </a:p>
+        </p:txBody>
+      </p:sp>
+      <p:sp>
+        <p:nvSpPr>
+          <p:cNvPr id="14" name="Rounded Rectangle 13"/>
           <p:cNvSpPr/>
           <p:nvPr/>
         </p:nvSpPr>
         <p:spPr>
           <a:xfrm>
-            <a:off x="822960" y="2916936"/>
-            <a:ext cx="10515600" cy="566928"/>
+            <a:off x="822960" y="3657600"/>
+            <a:ext cx="10515600" cy="960120"/>
           </a:xfrm>
           <a:prstGeom prst="roundRect">
             <a:avLst>
@@ -11913,19 +12951,20 @@
           <a:lstStyle/>
           <a:p>
             <a:pPr algn="ctr"/>
-          </a:p>
-        </p:txBody>
-      </p:sp>
-      <p:sp>
-        <p:nvSpPr>
-          <p:cNvPr id="16" name="TextBox 15"/>
+            <a:endParaRPr/>
+          </a:p>
+        </p:txBody>
+      </p:sp>
+      <p:sp>
+        <p:nvSpPr>
+          <p:cNvPr id="15" name="TextBox 14"/>
           <p:cNvSpPr txBox="1"/>
           <p:nvPr/>
         </p:nvSpPr>
         <p:spPr>
           <a:xfrm>
-            <a:off x="1051560" y="3035808"/>
-            <a:ext cx="457200" cy="365760"/>
+            <a:off x="1051560" y="3913632"/>
+            <a:ext cx="1005840" cy="365760"/>
           </a:xfrm>
           <a:prstGeom prst="rect">
             <a:avLst/>
@@ -11944,27 +12983,27 @@
               </a:lnSpc>
             </a:pPr>
             <a:r>
-              <a:rPr sz="1500" b="1">
+              <a:rPr sz="1200" b="1">
                 <a:solidFill>
                   <a:srgbClr val="0B6E5E"/>
                 </a:solidFill>
                 <a:latin typeface="Consolas"/>
               </a:rPr>
-              <a:t>3</a:t>
-            </a:r>
-          </a:p>
-        </p:txBody>
-      </p:sp>
-      <p:sp>
-        <p:nvSpPr>
-          <p:cNvPr id="17" name="TextBox 16"/>
+              <a:t>한계</a:t>
+            </a:r>
+          </a:p>
+        </p:txBody>
+      </p:sp>
+      <p:sp>
+        <p:nvSpPr>
+          <p:cNvPr id="16" name="TextBox 15"/>
           <p:cNvSpPr txBox="1"/>
           <p:nvPr/>
         </p:nvSpPr>
         <p:spPr>
           <a:xfrm>
-            <a:off x="1645920" y="3044952"/>
-            <a:ext cx="2743200" cy="365760"/>
+            <a:off x="2103120" y="3767328"/>
+            <a:ext cx="9052560" cy="320040"/>
           </a:xfrm>
           <a:prstGeom prst="rect">
             <a:avLst/>
@@ -11983,27 +13022,27 @@
               </a:lnSpc>
             </a:pPr>
             <a:r>
-              <a:rPr sz="1350" b="1">
+              <a:rPr sz="1400" b="1">
                 <a:solidFill>
                   <a:srgbClr val="131A19"/>
                 </a:solidFill>
                 <a:latin typeface="맑은 고딕"/>
               </a:rPr>
-              <a:t>설계 선택</a:t>
-            </a:r>
-          </a:p>
-        </p:txBody>
-      </p:sp>
-      <p:sp>
-        <p:nvSpPr>
-          <p:cNvPr id="18" name="TextBox 17"/>
+              <a:t>선형 방법의 천장은 19.80 dB</a:t>
+            </a:r>
+          </a:p>
+        </p:txBody>
+      </p:sp>
+      <p:sp>
+        <p:nvSpPr>
+          <p:cNvPr id="17" name="TextBox 16"/>
           <p:cNvSpPr txBox="1"/>
           <p:nvPr/>
         </p:nvSpPr>
         <p:spPr>
           <a:xfrm>
-            <a:off x="4480560" y="3072384"/>
-            <a:ext cx="4937760" cy="365760"/>
+            <a:off x="2103120" y="4114800"/>
+            <a:ext cx="9052560" cy="457200"/>
           </a:xfrm>
           <a:prstGeom prst="rect">
             <a:avLst/>
@@ -12028,60 +13067,21 @@
                 </a:solidFill>
                 <a:latin typeface="맑은 고딕"/>
               </a:rPr>
-              <a:t>왜 전개형인가 · σ 를 라벨 없이 읽는 법</a:t>
-            </a:r>
-          </a:p>
-        </p:txBody>
-      </p:sp>
-      <p:sp>
-        <p:nvSpPr>
-          <p:cNvPr id="19" name="TextBox 18"/>
-          <p:cNvSpPr txBox="1"/>
-          <p:nvPr/>
-        </p:nvSpPr>
-        <p:spPr>
-          <a:xfrm>
-            <a:off x="9418320" y="3072384"/>
-            <a:ext cx="1737360" cy="365760"/>
-          </a:xfrm>
-          <a:prstGeom prst="rect">
-            <a:avLst/>
-          </a:prstGeom>
-          <a:noFill/>
-        </p:spPr>
-        <p:txBody>
-          <a:bodyPr wrap="square" anchor="t">
-            <a:spAutoFit/>
-          </a:bodyPr>
-          <a:lstStyle/>
-          <a:p>
-            <a:pPr algn="r">
-              <a:lnSpc>
-                <a:spcPct val="125000"/>
-              </a:lnSpc>
-            </a:pPr>
-            <a:r>
-              <a:rPr sz="1050" b="0">
-                <a:solidFill>
-                  <a:srgbClr val="0B6E5E"/>
-                </a:solidFill>
-                <a:latin typeface="Consolas"/>
-              </a:rPr>
-              <a:t>요구사항 3</a:t>
-            </a:r>
-          </a:p>
-        </p:txBody>
-      </p:sp>
-      <p:sp>
-        <p:nvSpPr>
-          <p:cNvPr id="20" name="Rounded Rectangle 19"/>
+              <a:t>정답을 알고 만든 최고의 선형 필터(오라클 위너)조차 그렇다. 그 위는 비선형 사전지식의 몫이다.</a:t>
+            </a:r>
+          </a:p>
+        </p:txBody>
+      </p:sp>
+      <p:sp>
+        <p:nvSpPr>
+          <p:cNvPr id="18" name="Rounded Rectangle 17"/>
           <p:cNvSpPr/>
           <p:nvPr/>
         </p:nvSpPr>
         <p:spPr>
           <a:xfrm>
-            <a:off x="822960" y="3575304"/>
-            <a:ext cx="10515600" cy="566928"/>
+            <a:off x="822960" y="4709160"/>
+            <a:ext cx="10515600" cy="960120"/>
           </a:xfrm>
           <a:prstGeom prst="roundRect">
             <a:avLst>
@@ -12117,19 +13117,20 @@
           <a:lstStyle/>
           <a:p>
             <a:pPr algn="ctr"/>
-          </a:p>
-        </p:txBody>
-      </p:sp>
-      <p:sp>
-        <p:nvSpPr>
-          <p:cNvPr id="21" name="TextBox 20"/>
+            <a:endParaRPr/>
+          </a:p>
+        </p:txBody>
+      </p:sp>
+      <p:sp>
+        <p:nvSpPr>
+          <p:cNvPr id="19" name="TextBox 18"/>
           <p:cNvSpPr txBox="1"/>
           <p:nvPr/>
         </p:nvSpPr>
         <p:spPr>
           <a:xfrm>
-            <a:off x="1051560" y="3694176"/>
-            <a:ext cx="457200" cy="365760"/>
+            <a:off x="1051560" y="4965192"/>
+            <a:ext cx="1005840" cy="365760"/>
           </a:xfrm>
           <a:prstGeom prst="rect">
             <a:avLst/>
@@ -12148,27 +13149,27 @@
               </a:lnSpc>
             </a:pPr>
             <a:r>
-              <a:rPr sz="1500" b="1">
+              <a:rPr sz="1200" b="1">
                 <a:solidFill>
                   <a:srgbClr val="0B6E5E"/>
                 </a:solidFill>
                 <a:latin typeface="Consolas"/>
               </a:rPr>
-              <a:t>4</a:t>
-            </a:r>
-          </a:p>
-        </p:txBody>
-      </p:sp>
-      <p:sp>
-        <p:nvSpPr>
-          <p:cNvPr id="22" name="TextBox 21"/>
+              <a:t>답</a:t>
+            </a:r>
+          </a:p>
+        </p:txBody>
+      </p:sp>
+      <p:sp>
+        <p:nvSpPr>
+          <p:cNvPr id="20" name="TextBox 19"/>
           <p:cNvSpPr txBox="1"/>
           <p:nvPr/>
         </p:nvSpPr>
         <p:spPr>
           <a:xfrm>
-            <a:off x="1645920" y="3703320"/>
-            <a:ext cx="2743200" cy="365760"/>
+            <a:off x="2103120" y="4818888"/>
+            <a:ext cx="9052560" cy="320040"/>
           </a:xfrm>
           <a:prstGeom prst="rect">
             <a:avLst/>
@@ -12187,27 +13188,27 @@
               </a:lnSpc>
             </a:pPr>
             <a:r>
-              <a:rPr sz="1350" b="1">
+              <a:rPr sz="1400" b="1">
                 <a:solidFill>
                   <a:srgbClr val="131A19"/>
                 </a:solidFill>
                 <a:latin typeface="맑은 고딕"/>
               </a:rPr>
-              <a:t>복원 결과</a:t>
-            </a:r>
-          </a:p>
-        </p:txBody>
-      </p:sp>
-      <p:sp>
-        <p:nvSpPr>
-          <p:cNvPr id="23" name="TextBox 22"/>
+              <a:t>전개형 — 물리 제약과 학습된 사전지식을 번갈아</a:t>
+            </a:r>
+          </a:p>
+        </p:txBody>
+      </p:sp>
+      <p:sp>
+        <p:nvSpPr>
+          <p:cNvPr id="21" name="TextBox 20"/>
           <p:cNvSpPr txBox="1"/>
           <p:nvPr/>
         </p:nvSpPr>
         <p:spPr>
           <a:xfrm>
-            <a:off x="4480560" y="3730752"/>
-            <a:ext cx="4937760" cy="365760"/>
+            <a:off x="2103120" y="5166360"/>
+            <a:ext cx="9052560" cy="457200"/>
           </a:xfrm>
           <a:prstGeom prst="rect">
             <a:avLst/>
@@ -12232,60 +13233,21 @@
                 </a:solidFill>
                 <a:latin typeface="맑은 고딕"/>
               </a:rPr>
-              <a:t>before / after / difference / GT · 노이즈별 격자</a:t>
-            </a:r>
-          </a:p>
-        </p:txBody>
-      </p:sp>
-      <p:sp>
-        <p:nvSpPr>
-          <p:cNvPr id="24" name="TextBox 23"/>
-          <p:cNvSpPr txBox="1"/>
-          <p:nvPr/>
-        </p:nvSpPr>
-        <p:spPr>
-          <a:xfrm>
-            <a:off x="9418320" y="3730752"/>
-            <a:ext cx="1737360" cy="365760"/>
-          </a:xfrm>
-          <a:prstGeom prst="rect">
-            <a:avLst/>
-          </a:prstGeom>
-          <a:noFill/>
-        </p:spPr>
-        <p:txBody>
-          <a:bodyPr wrap="square" anchor="t">
-            <a:spAutoFit/>
-          </a:bodyPr>
-          <a:lstStyle/>
-          <a:p>
-            <a:pPr algn="r">
-              <a:lnSpc>
-                <a:spcPct val="125000"/>
-              </a:lnSpc>
-            </a:pPr>
-            <a:r>
-              <a:rPr sz="1050" b="0">
-                <a:solidFill>
-                  <a:srgbClr val="0B6E5E"/>
-                </a:solidFill>
-                <a:latin typeface="Consolas"/>
-              </a:rPr>
-              <a:t>요구사항 2</a:t>
-            </a:r>
-          </a:p>
-        </p:txBody>
-      </p:sp>
-      <p:sp>
-        <p:nvSpPr>
-          <p:cNvPr id="25" name="Rounded Rectangle 24"/>
+              <a:t>역산은 닫힌 해로 정확히 풀고, 네트워크는 역산이 포기한 주파수를 메우는 데만 용량을 쓴다. σ 는 측정치에서 읽어 장마다 다른 노이즈 세기에 맞춘다.</a:t>
+            </a:r>
+          </a:p>
+        </p:txBody>
+      </p:sp>
+      <p:sp>
+        <p:nvSpPr>
+          <p:cNvPr id="22" name="Rounded Rectangle 21"/>
           <p:cNvSpPr/>
           <p:nvPr/>
         </p:nvSpPr>
         <p:spPr>
           <a:xfrm>
-            <a:off x="822960" y="4233672"/>
-            <a:ext cx="10515600" cy="566928"/>
+            <a:off x="822960" y="5696712"/>
+            <a:ext cx="10515600" cy="777240"/>
           </a:xfrm>
           <a:prstGeom prst="roundRect">
             <a:avLst>
@@ -12293,11 +13255,11 @@
             </a:avLst>
           </a:prstGeom>
           <a:solidFill>
-            <a:srgbClr val="F3F6F5"/>
+            <a:srgbClr val="DCEDE8"/>
           </a:solidFill>
           <a:ln w="9525">
             <a:solidFill>
-              <a:srgbClr val="DCE3E0"/>
+              <a:srgbClr val="0B6E5E"/>
             </a:solidFill>
           </a:ln>
           <a:effectLst/>
@@ -12321,19 +13283,20 @@
           <a:lstStyle/>
           <a:p>
             <a:pPr algn="ctr"/>
-          </a:p>
-        </p:txBody>
-      </p:sp>
-      <p:sp>
-        <p:nvSpPr>
-          <p:cNvPr id="26" name="TextBox 25"/>
+            <a:endParaRPr/>
+          </a:p>
+        </p:txBody>
+      </p:sp>
+      <p:sp>
+        <p:nvSpPr>
+          <p:cNvPr id="23" name="TextBox 22"/>
           <p:cNvSpPr txBox="1"/>
           <p:nvPr/>
         </p:nvSpPr>
         <p:spPr>
           <a:xfrm>
-            <a:off x="1051560" y="4352544"/>
-            <a:ext cx="457200" cy="365760"/>
+            <a:off x="1051560" y="5856732"/>
+            <a:ext cx="10058400" cy="457200"/>
           </a:xfrm>
           <a:prstGeom prst="rect">
             <a:avLst/>
@@ -12352,499 +13315,94 @@
               </a:lnSpc>
             </a:pPr>
             <a:r>
-              <a:rPr sz="1500" b="1">
-                <a:solidFill>
-                  <a:srgbClr val="0B6E5E"/>
-                </a:solidFill>
-                <a:latin typeface="Consolas"/>
-              </a:rPr>
-              <a:t>5</a:t>
-            </a:r>
-          </a:p>
-        </p:txBody>
-      </p:sp>
-      <p:sp>
-        <p:nvSpPr>
-          <p:cNvPr id="27" name="TextBox 26"/>
-          <p:cNvSpPr txBox="1"/>
-          <p:nvPr/>
-        </p:nvSpPr>
-        <p:spPr>
-          <a:xfrm>
-            <a:off x="1645920" y="4361688"/>
-            <a:ext cx="2743200" cy="365760"/>
-          </a:xfrm>
-          <a:prstGeom prst="rect">
-            <a:avLst/>
-          </a:prstGeom>
-          <a:noFill/>
-        </p:spPr>
-        <p:txBody>
-          <a:bodyPr wrap="square" anchor="t">
-            <a:spAutoFit/>
-          </a:bodyPr>
-          <a:lstStyle/>
-          <a:p>
-            <a:pPr algn="l">
-              <a:lnSpc>
-                <a:spcPct val="125000"/>
-              </a:lnSpc>
-            </a:pPr>
-            <a:r>
-              <a:rPr sz="1350" b="1">
+              <a:rPr sz="1300" b="1" dirty="0" err="1">
                 <a:solidFill>
                   <a:srgbClr val="131A19"/>
                 </a:solidFill>
                 <a:latin typeface="맑은 고딕"/>
               </a:rPr>
-              <a:t>결과 분석</a:t>
-            </a:r>
-          </a:p>
-        </p:txBody>
-      </p:sp>
-      <p:sp>
-        <p:nvSpPr>
-          <p:cNvPr id="28" name="TextBox 27"/>
-          <p:cNvSpPr txBox="1"/>
-          <p:nvPr/>
-        </p:nvSpPr>
-        <p:spPr>
-          <a:xfrm>
-            <a:off x="4480560" y="4389120"/>
-            <a:ext cx="4937760" cy="365760"/>
-          </a:xfrm>
-          <a:prstGeom prst="rect">
-            <a:avLst/>
-          </a:prstGeom>
-          <a:noFill/>
-        </p:spPr>
-        <p:txBody>
-          <a:bodyPr wrap="square" anchor="t">
-            <a:spAutoFit/>
-          </a:bodyPr>
-          <a:lstStyle/>
-          <a:p>
-            <a:pPr algn="l">
-              <a:lnSpc>
-                <a:spcPct val="125000"/>
-              </a:lnSpc>
-            </a:pPr>
-            <a:r>
-              <a:rPr sz="1150" b="0">
-                <a:solidFill>
-                  <a:srgbClr val="66756F"/>
+              <a:t>결과</a:t>
+            </a:r>
+            <a:r>
+              <a:rPr sz="1300" b="1" dirty="0">
+                <a:solidFill>
+                  <a:srgbClr val="131A19"/>
                 </a:solidFill>
                 <a:latin typeface="맑은 고딕"/>
               </a:rPr>
-              <a:t>어떤 노이즈·어떤 이미지에 취약한가 · σ ablation</a:t>
-            </a:r>
-          </a:p>
-        </p:txBody>
-      </p:sp>
-      <p:sp>
-        <p:nvSpPr>
-          <p:cNvPr id="29" name="TextBox 28"/>
-          <p:cNvSpPr txBox="1"/>
-          <p:nvPr/>
-        </p:nvSpPr>
-        <p:spPr>
-          <a:xfrm>
-            <a:off x="9418320" y="4389120"/>
-            <a:ext cx="1737360" cy="365760"/>
-          </a:xfrm>
-          <a:prstGeom prst="rect">
-            <a:avLst/>
-          </a:prstGeom>
-          <a:noFill/>
-        </p:spPr>
-        <p:txBody>
-          <a:bodyPr wrap="square" anchor="t">
-            <a:spAutoFit/>
-          </a:bodyPr>
-          <a:lstStyle/>
-          <a:p>
-            <a:pPr algn="r">
-              <a:lnSpc>
-                <a:spcPct val="125000"/>
-              </a:lnSpc>
-            </a:pPr>
-            <a:r>
-              <a:rPr sz="1050" b="0">
-                <a:solidFill>
-                  <a:srgbClr val="0B6E5E"/>
-                </a:solidFill>
-                <a:latin typeface="Consolas"/>
-              </a:rPr>
-              <a:t>tips</a:t>
-            </a:r>
-          </a:p>
-        </p:txBody>
-      </p:sp>
-      <p:sp>
-        <p:nvSpPr>
-          <p:cNvPr id="30" name="Rounded Rectangle 29"/>
-          <p:cNvSpPr/>
-          <p:nvPr/>
-        </p:nvSpPr>
-        <p:spPr>
-          <a:xfrm>
-            <a:off x="822960" y="4892040"/>
-            <a:ext cx="10515600" cy="566928"/>
-          </a:xfrm>
-          <a:prstGeom prst="roundRect">
-            <a:avLst>
-              <a:gd name="adj" fmla="val 4000"/>
-            </a:avLst>
-          </a:prstGeom>
-          <a:solidFill>
-            <a:srgbClr val="F3F6F5"/>
-          </a:solidFill>
-          <a:ln w="9525">
-            <a:solidFill>
-              <a:srgbClr val="DCE3E0"/>
-            </a:solidFill>
-          </a:ln>
-          <a:effectLst/>
-        </p:spPr>
-        <p:style>
-          <a:lnRef idx="1">
-            <a:schemeClr val="accent1"/>
-          </a:lnRef>
-          <a:fillRef idx="3">
-            <a:schemeClr val="accent1"/>
-          </a:fillRef>
-          <a:effectRef idx="2">
-            <a:schemeClr val="accent1"/>
-          </a:effectRef>
-          <a:fontRef idx="minor">
-            <a:schemeClr val="lt1"/>
-          </a:fontRef>
-        </p:style>
-        <p:txBody>
-          <a:bodyPr rtlCol="0" anchor="ctr"/>
-          <a:lstStyle/>
-          <a:p>
-            <a:pPr algn="ctr"/>
-          </a:p>
-        </p:txBody>
-      </p:sp>
-      <p:sp>
-        <p:nvSpPr>
-          <p:cNvPr id="31" name="TextBox 30"/>
-          <p:cNvSpPr txBox="1"/>
-          <p:nvPr/>
-        </p:nvSpPr>
-        <p:spPr>
-          <a:xfrm>
-            <a:off x="1051560" y="5010912"/>
-            <a:ext cx="457200" cy="365760"/>
-          </a:xfrm>
-          <a:prstGeom prst="rect">
-            <a:avLst/>
-          </a:prstGeom>
-          <a:noFill/>
-        </p:spPr>
-        <p:txBody>
-          <a:bodyPr wrap="square" anchor="t">
-            <a:spAutoFit/>
-          </a:bodyPr>
-          <a:lstStyle/>
-          <a:p>
-            <a:pPr algn="l">
-              <a:lnSpc>
-                <a:spcPct val="125000"/>
-              </a:lnSpc>
-            </a:pPr>
-            <a:r>
-              <a:rPr sz="1500" b="1">
-                <a:solidFill>
-                  <a:srgbClr val="0B6E5E"/>
-                </a:solidFill>
-                <a:latin typeface="Consolas"/>
-              </a:rPr>
-              <a:t>6</a:t>
-            </a:r>
-          </a:p>
-        </p:txBody>
-      </p:sp>
-      <p:sp>
-        <p:nvSpPr>
-          <p:cNvPr id="32" name="TextBox 31"/>
-          <p:cNvSpPr txBox="1"/>
-          <p:nvPr/>
-        </p:nvSpPr>
-        <p:spPr>
-          <a:xfrm>
-            <a:off x="1645920" y="5020056"/>
-            <a:ext cx="2743200" cy="365760"/>
-          </a:xfrm>
-          <a:prstGeom prst="rect">
-            <a:avLst/>
-          </a:prstGeom>
-          <a:noFill/>
-        </p:spPr>
-        <p:txBody>
-          <a:bodyPr wrap="square" anchor="t">
-            <a:spAutoFit/>
-          </a:bodyPr>
-          <a:lstStyle/>
-          <a:p>
-            <a:pPr algn="l">
-              <a:lnSpc>
-                <a:spcPct val="125000"/>
-              </a:lnSpc>
-            </a:pPr>
-            <a:r>
-              <a:rPr sz="1350" b="1">
+              <a:t>   29.25 dB / 0.8777   ·   </a:t>
+            </a:r>
+            <a:r>
+              <a:rPr sz="1300" b="1" dirty="0" err="1">
                 <a:solidFill>
                   <a:srgbClr val="131A19"/>
                 </a:solidFill>
                 <a:latin typeface="맑은 고딕"/>
               </a:rPr>
-              <a:t>label-free</a:t>
-            </a:r>
-          </a:p>
-        </p:txBody>
-      </p:sp>
-      <p:sp>
-        <p:nvSpPr>
-          <p:cNvPr id="33" name="TextBox 32"/>
-          <p:cNvSpPr txBox="1"/>
-          <p:nvPr/>
-        </p:nvSpPr>
-        <p:spPr>
-          <a:xfrm>
-            <a:off x="4480560" y="5047488"/>
-            <a:ext cx="4937760" cy="365760"/>
-          </a:xfrm>
-          <a:prstGeom prst="rect">
-            <a:avLst/>
-          </a:prstGeom>
-          <a:noFill/>
-        </p:spPr>
-        <p:txBody>
-          <a:bodyPr wrap="square" anchor="t">
-            <a:spAutoFit/>
-          </a:bodyPr>
-          <a:lstStyle/>
-          <a:p>
-            <a:pPr algn="l">
-              <a:lnSpc>
-                <a:spcPct val="125000"/>
-              </a:lnSpc>
-            </a:pPr>
-            <a:r>
-              <a:rPr sz="1150" b="0">
-                <a:solidFill>
-                  <a:srgbClr val="66756F"/>
+              <a:t>배포</a:t>
+            </a:r>
+            <a:r>
+              <a:rPr sz="1300" b="1" dirty="0">
+                <a:solidFill>
+                  <a:srgbClr val="131A19"/>
                 </a:solidFill>
                 <a:latin typeface="맑은 고딕"/>
               </a:rPr>
-              <a:t>정답을 한 장도 쓰지 않고 푼다</a:t>
-            </a:r>
-          </a:p>
-        </p:txBody>
-      </p:sp>
-      <p:sp>
-        <p:nvSpPr>
-          <p:cNvPr id="34" name="TextBox 33"/>
-          <p:cNvSpPr txBox="1"/>
-          <p:nvPr/>
-        </p:nvSpPr>
-        <p:spPr>
-          <a:xfrm>
-            <a:off x="9418320" y="5047488"/>
-            <a:ext cx="1737360" cy="365760"/>
-          </a:xfrm>
-          <a:prstGeom prst="rect">
-            <a:avLst/>
-          </a:prstGeom>
-          <a:noFill/>
-        </p:spPr>
-        <p:txBody>
-          <a:bodyPr wrap="square" anchor="t">
-            <a:spAutoFit/>
-          </a:bodyPr>
-          <a:lstStyle/>
-          <a:p>
-            <a:pPr algn="r">
-              <a:lnSpc>
-                <a:spcPct val="125000"/>
-              </a:lnSpc>
-            </a:pPr>
-            <a:r>
-              <a:rPr sz="1050" b="0">
-                <a:solidFill>
-                  <a:srgbClr val="0B6E5E"/>
-                </a:solidFill>
-                <a:latin typeface="Consolas"/>
-              </a:rPr>
-              <a:t>요구사항 4 · 보너스</a:t>
-            </a:r>
-          </a:p>
-        </p:txBody>
-      </p:sp>
-      <p:sp>
-        <p:nvSpPr>
-          <p:cNvPr id="35" name="Rounded Rectangle 34"/>
-          <p:cNvSpPr/>
-          <p:nvPr/>
-        </p:nvSpPr>
-        <p:spPr>
-          <a:xfrm>
-            <a:off x="822960" y="5550408"/>
-            <a:ext cx="10515600" cy="566928"/>
-          </a:xfrm>
-          <a:prstGeom prst="roundRect">
-            <a:avLst>
-              <a:gd name="adj" fmla="val 4000"/>
-            </a:avLst>
-          </a:prstGeom>
-          <a:solidFill>
-            <a:srgbClr val="F3F6F5"/>
-          </a:solidFill>
-          <a:ln w="9525">
-            <a:solidFill>
-              <a:srgbClr val="DCE3E0"/>
-            </a:solidFill>
-          </a:ln>
-          <a:effectLst/>
-        </p:spPr>
-        <p:style>
-          <a:lnRef idx="1">
-            <a:schemeClr val="accent1"/>
-          </a:lnRef>
-          <a:fillRef idx="3">
-            <a:schemeClr val="accent1"/>
-          </a:fillRef>
-          <a:effectRef idx="2">
-            <a:schemeClr val="accent1"/>
-          </a:effectRef>
-          <a:fontRef idx="minor">
-            <a:schemeClr val="lt1"/>
-          </a:fontRef>
-        </p:style>
-        <p:txBody>
-          <a:bodyPr rtlCol="0" anchor="ctr"/>
-          <a:lstStyle/>
-          <a:p>
-            <a:pPr algn="ctr"/>
-          </a:p>
-        </p:txBody>
-      </p:sp>
-      <p:sp>
-        <p:nvSpPr>
-          <p:cNvPr id="36" name="TextBox 35"/>
-          <p:cNvSpPr txBox="1"/>
-          <p:nvPr/>
-        </p:nvSpPr>
-        <p:spPr>
-          <a:xfrm>
-            <a:off x="1051560" y="5669280"/>
-            <a:ext cx="457200" cy="365760"/>
-          </a:xfrm>
-          <a:prstGeom prst="rect">
-            <a:avLst/>
-          </a:prstGeom>
-          <a:noFill/>
-        </p:spPr>
-        <p:txBody>
-          <a:bodyPr wrap="square" anchor="t">
-            <a:spAutoFit/>
-          </a:bodyPr>
-          <a:lstStyle/>
-          <a:p>
-            <a:pPr algn="l">
-              <a:lnSpc>
-                <a:spcPct val="125000"/>
-              </a:lnSpc>
-            </a:pPr>
-            <a:r>
-              <a:rPr sz="1500" b="1">
-                <a:solidFill>
-                  <a:srgbClr val="0B6E5E"/>
-                </a:solidFill>
-                <a:latin typeface="Consolas"/>
-              </a:rPr>
-              <a:t>7</a:t>
-            </a:r>
-          </a:p>
-        </p:txBody>
-      </p:sp>
-      <p:sp>
-        <p:nvSpPr>
-          <p:cNvPr id="37" name="TextBox 36"/>
-          <p:cNvSpPr txBox="1"/>
-          <p:nvPr/>
-        </p:nvSpPr>
-        <p:spPr>
-          <a:xfrm>
-            <a:off x="1645920" y="5678424"/>
-            <a:ext cx="2743200" cy="365760"/>
-          </a:xfrm>
-          <a:prstGeom prst="rect">
-            <a:avLst/>
-          </a:prstGeom>
-          <a:noFill/>
-        </p:spPr>
-        <p:txBody>
-          <a:bodyPr wrap="square" anchor="t">
-            <a:spAutoFit/>
-          </a:bodyPr>
-          <a:lstStyle/>
-          <a:p>
-            <a:pPr algn="l">
-              <a:lnSpc>
-                <a:spcPct val="125000"/>
-              </a:lnSpc>
-            </a:pPr>
-            <a:r>
-              <a:rPr sz="1350" b="1">
+              <a:t> baseline 25.01 / 0.8149 </a:t>
+            </a:r>
+            <a:r>
+              <a:rPr sz="1300" b="1" dirty="0" err="1">
                 <a:solidFill>
                   <a:srgbClr val="131A19"/>
                 </a:solidFill>
                 <a:latin typeface="맑은 고딕"/>
               </a:rPr>
-              <a:t>시도별 요약</a:t>
-            </a:r>
-          </a:p>
-        </p:txBody>
-      </p:sp>
-      <p:sp>
-        <p:nvSpPr>
-          <p:cNvPr id="38" name="TextBox 37"/>
-          <p:cNvSpPr txBox="1"/>
-          <p:nvPr/>
-        </p:nvSpPr>
-        <p:spPr>
-          <a:xfrm>
-            <a:off x="4480560" y="5705856"/>
-            <a:ext cx="4937760" cy="365760"/>
-          </a:xfrm>
-          <a:prstGeom prst="rect">
-            <a:avLst/>
-          </a:prstGeom>
-          <a:noFill/>
-        </p:spPr>
-        <p:txBody>
-          <a:bodyPr wrap="square" anchor="t">
-            <a:spAutoFit/>
-          </a:bodyPr>
-          <a:lstStyle/>
-          <a:p>
-            <a:pPr algn="l">
-              <a:lnSpc>
-                <a:spcPct val="125000"/>
-              </a:lnSpc>
-            </a:pPr>
-            <a:r>
-              <a:rPr sz="1150" b="0">
-                <a:solidFill>
-                  <a:srgbClr val="66756F"/>
+              <a:t>대비</a:t>
+            </a:r>
+            <a:r>
+              <a:rPr sz="1300" b="1" dirty="0">
+                <a:solidFill>
+                  <a:srgbClr val="131A19"/>
                 </a:solidFill>
                 <a:latin typeface="맑은 고딕"/>
               </a:rPr>
-              <a:t>무엇을 해봤고 무엇을 배웠나 · 검증 규칙</a:t>
+              <a:t> +4.24 dB · +0.0628   ·   </a:t>
+            </a:r>
+            <a:r>
+              <a:rPr sz="1300" b="1" dirty="0" err="1">
+                <a:solidFill>
+                  <a:srgbClr val="131A19"/>
+                </a:solidFill>
+                <a:latin typeface="맑은 고딕"/>
+              </a:rPr>
+              <a:t>통과</a:t>
+            </a:r>
+            <a:r>
+              <a:rPr sz="1300" b="1" dirty="0">
+                <a:solidFill>
+                  <a:srgbClr val="131A19"/>
+                </a:solidFill>
+                <a:latin typeface="맑은 고딕"/>
+              </a:rPr>
+              <a:t> </a:t>
+            </a:r>
+            <a:r>
+              <a:rPr sz="1300" b="1" dirty="0" err="1">
+                <a:solidFill>
+                  <a:srgbClr val="131A19"/>
+                </a:solidFill>
+                <a:latin typeface="맑은 고딕"/>
+              </a:rPr>
+              <a:t>기준</a:t>
+            </a:r>
+            <a:r>
+              <a:rPr sz="1300" b="1" dirty="0">
+                <a:solidFill>
+                  <a:srgbClr val="131A19"/>
+                </a:solidFill>
+                <a:latin typeface="맑은 고딕"/>
+              </a:rPr>
+              <a:t> 26 / 0.83</a:t>
             </a:r>
           </a:p>
         </p:txBody>
@@ -12858,7 +13416,7 @@
 </file>
 
 <file path=ppt/slides/slide4.xml><?xml version="1.0" encoding="utf-8"?>
-<p:sld xmlns:a="http://schemas.openxmlformats.org/drawingml/2006/main" xmlns:p="http://schemas.openxmlformats.org/presentationml/2006/main" xmlns:r="http://schemas.openxmlformats.org/officeDocument/2006/relationships">
+<p:sld xmlns:a="http://schemas.openxmlformats.org/drawingml/2006/main" xmlns:r="http://schemas.openxmlformats.org/officeDocument/2006/relationships" xmlns:p="http://schemas.openxmlformats.org/presentationml/2006/main">
   <p:cSld>
     <p:bg>
       <p:bgPr>
@@ -12874,7 +13432,14 @@
         <p:cNvGrpSpPr/>
         <p:nvPr/>
       </p:nvGrpSpPr>
-      <p:grpSpPr/>
+      <p:grpSpPr>
+        <a:xfrm>
+          <a:off x="0" y="0"/>
+          <a:ext cx="0" cy="0"/>
+          <a:chOff x="0" y="0"/>
+          <a:chExt cx="0" cy="0"/>
+        </a:xfrm>
+      </p:grpSpPr>
       <p:sp>
         <p:nvSpPr>
           <p:cNvPr id="2" name="TextBox 1"/>
@@ -13033,6 +13598,7 @@
           <a:lstStyle/>
           <a:p>
             <a:pPr algn="ctr"/>
+            <a:endParaRPr/>
           </a:p>
         </p:txBody>
       </p:sp>
@@ -13081,6 +13647,7 @@
           <a:lstStyle/>
           <a:p>
             <a:pPr algn="ctr"/>
+            <a:endParaRPr/>
           </a:p>
         </p:txBody>
       </p:sp>
@@ -13203,6 +13770,7 @@
           <a:lstStyle/>
           <a:p>
             <a:pPr algn="ctr"/>
+            <a:endParaRPr/>
           </a:p>
         </p:txBody>
       </p:sp>
@@ -13251,6 +13819,7 @@
           <a:lstStyle/>
           <a:p>
             <a:pPr algn="ctr"/>
+            <a:endParaRPr/>
           </a:p>
         </p:txBody>
       </p:sp>
@@ -13374,6 +13943,7 @@
           <a:lstStyle/>
           <a:p>
             <a:pPr algn="ctr"/>
+            <a:endParaRPr/>
           </a:p>
         </p:txBody>
       </p:sp>
@@ -13422,6 +13992,7 @@
           <a:lstStyle/>
           <a:p>
             <a:pPr algn="ctr"/>
+            <a:endParaRPr/>
           </a:p>
         </p:txBody>
       </p:sp>
@@ -13546,6 +14117,7 @@
           <a:lstStyle/>
           <a:p>
             <a:pPr algn="ctr"/>
+            <a:endParaRPr/>
           </a:p>
         </p:txBody>
       </p:sp>
@@ -13594,6 +14166,7 @@
           <a:lstStyle/>
           <a:p>
             <a:pPr algn="ctr"/>
+            <a:endParaRPr/>
           </a:p>
         </p:txBody>
       </p:sp>
@@ -13717,6 +14290,7 @@
           <a:lstStyle/>
           <a:p>
             <a:pPr algn="ctr"/>
+            <a:endParaRPr/>
           </a:p>
         </p:txBody>
       </p:sp>
@@ -13765,6 +14339,7 @@
           <a:lstStyle/>
           <a:p>
             <a:pPr algn="ctr"/>
+            <a:endParaRPr/>
           </a:p>
         </p:txBody>
       </p:sp>
@@ -13930,6 +14505,7 @@
           <a:lstStyle/>
           <a:p>
             <a:pPr algn="ctr"/>
+            <a:endParaRPr/>
           </a:p>
         </p:txBody>
       </p:sp>
@@ -14013,7 +14589,7 @@
 </file>
 
 <file path=ppt/slides/slide5.xml><?xml version="1.0" encoding="utf-8"?>
-<p:sld xmlns:a="http://schemas.openxmlformats.org/drawingml/2006/main" xmlns:p="http://schemas.openxmlformats.org/presentationml/2006/main" xmlns:r="http://schemas.openxmlformats.org/officeDocument/2006/relationships">
+<p:sld xmlns:a="http://schemas.openxmlformats.org/drawingml/2006/main" xmlns:r="http://schemas.openxmlformats.org/officeDocument/2006/relationships" xmlns:p="http://schemas.openxmlformats.org/presentationml/2006/main">
   <p:cSld>
     <p:bg>
       <p:bgPr>
@@ -14029,7 +14605,14 @@
         <p:cNvGrpSpPr/>
         <p:nvPr/>
       </p:nvGrpSpPr>
-      <p:grpSpPr/>
+      <p:grpSpPr>
+        <a:xfrm>
+          <a:off x="0" y="0"/>
+          <a:ext cx="0" cy="0"/>
+          <a:chOff x="0" y="0"/>
+          <a:chExt cx="0" cy="0"/>
+        </a:xfrm>
+      </p:grpSpPr>
       <p:sp>
         <p:nvSpPr>
           <p:cNvPr id="2" name="TextBox 1"/>
@@ -14188,6 +14771,7 @@
           <a:lstStyle/>
           <a:p>
             <a:pPr algn="ctr"/>
+            <a:endParaRPr/>
           </a:p>
         </p:txBody>
       </p:sp>
@@ -14201,7 +14785,7 @@
         </p:nvGraphicFramePr>
         <p:xfrm>
           <a:off x="822960" y="1737360"/>
-          <a:ext cx="10515598" cy="1097280"/>
+          <a:ext cx="10515598" cy="1152144"/>
         </p:xfrm>
         <a:graphic>
           <a:graphicData uri="http://schemas.openxmlformats.org/drawingml/2006/table">
@@ -14210,10 +14794,34 @@
                 <a:tableStyleId>{5C22544A-7EE6-4342-B048-85BDC9FD1C3A}</a:tableStyleId>
               </a:tblPr>
               <a:tblGrid>
-                <a:gridCol w="1660357"/>
-                <a:gridCol w="2767263"/>
-                <a:gridCol w="2767263"/>
-                <a:gridCol w="3320715"/>
+                <a:gridCol w="1660357">
+                  <a:extLst>
+                    <a:ext uri="{9D8B030D-6E8A-4147-A177-3AD203B41FA5}">
+                      <a16:colId xmlns:a16="http://schemas.microsoft.com/office/drawing/2014/main" val="20000"/>
+                    </a:ext>
+                  </a:extLst>
+                </a:gridCol>
+                <a:gridCol w="2767263">
+                  <a:extLst>
+                    <a:ext uri="{9D8B030D-6E8A-4147-A177-3AD203B41FA5}">
+                      <a16:colId xmlns:a16="http://schemas.microsoft.com/office/drawing/2014/main" val="20001"/>
+                    </a:ext>
+                  </a:extLst>
+                </a:gridCol>
+                <a:gridCol w="2767263">
+                  <a:extLst>
+                    <a:ext uri="{9D8B030D-6E8A-4147-A177-3AD203B41FA5}">
+                      <a16:colId xmlns:a16="http://schemas.microsoft.com/office/drawing/2014/main" val="20002"/>
+                    </a:ext>
+                  </a:extLst>
+                </a:gridCol>
+                <a:gridCol w="3320715">
+                  <a:extLst>
+                    <a:ext uri="{9D8B030D-6E8A-4147-A177-3AD203B41FA5}">
+                      <a16:colId xmlns:a16="http://schemas.microsoft.com/office/drawing/2014/main" val="20003"/>
+                    </a:ext>
+                  </a:extLst>
+                </a:gridCol>
               </a:tblGrid>
               <a:tr h="274320">
                 <a:tc>
@@ -14222,6 +14830,7 @@
                     <a:lstStyle/>
                     <a:p>
                       <a:pPr algn="l"/>
+                      <a:endParaRPr/>
                     </a:p>
                   </a:txBody>
                   <a:tcPr marL="82296" marR="82296" marT="27432" marB="27432" anchor="ctr">
@@ -14299,6 +14908,11 @@
                     </a:solidFill>
                   </a:tcPr>
                 </a:tc>
+                <a:extLst>
+                  <a:ext uri="{0D108BD9-81ED-4DB2-BD59-A6C34878D82A}">
+                    <a16:rowId xmlns:a16="http://schemas.microsoft.com/office/drawing/2014/main" val="10000"/>
+                  </a:ext>
+                </a:extLst>
               </a:tr>
               <a:tr h="274320">
                 <a:tc>
@@ -14393,6 +15007,11 @@
                     </a:solidFill>
                   </a:tcPr>
                 </a:tc>
+                <a:extLst>
+                  <a:ext uri="{0D108BD9-81ED-4DB2-BD59-A6C34878D82A}">
+                    <a16:rowId xmlns:a16="http://schemas.microsoft.com/office/drawing/2014/main" val="10001"/>
+                  </a:ext>
+                </a:extLst>
               </a:tr>
               <a:tr h="274320">
                 <a:tc>
@@ -14487,6 +15106,11 @@
                     </a:solidFill>
                   </a:tcPr>
                 </a:tc>
+                <a:extLst>
+                  <a:ext uri="{0D108BD9-81ED-4DB2-BD59-A6C34878D82A}">
+                    <a16:rowId xmlns:a16="http://schemas.microsoft.com/office/drawing/2014/main" val="10002"/>
+                  </a:ext>
+                </a:extLst>
               </a:tr>
               <a:tr h="274320">
                 <a:tc>
@@ -14581,6 +15205,11 @@
                     </a:solidFill>
                   </a:tcPr>
                 </a:tc>
+                <a:extLst>
+                  <a:ext uri="{0D108BD9-81ED-4DB2-BD59-A6C34878D82A}">
+                    <a16:rowId xmlns:a16="http://schemas.microsoft.com/office/drawing/2014/main" val="10003"/>
+                  </a:ext>
+                </a:extLst>
               </a:tr>
             </a:tbl>
           </a:graphicData>
@@ -14631,6 +15260,7 @@
           <a:lstStyle/>
           <a:p>
             <a:pPr algn="ctr"/>
+            <a:endParaRPr/>
           </a:p>
         </p:txBody>
       </p:sp>
@@ -14716,15 +15346,12 @@
                 <a:spcPct val="125000"/>
               </a:lnSpc>
             </a:pPr>
-            <a:r>
-              <a:rPr sz="1400" b="0">
-                <a:solidFill>
-                  <a:srgbClr val="3C4947"/>
-                </a:solidFill>
-                <a:latin typeface="맑은 고딕"/>
-              </a:rPr>
-              <a:t/>
-            </a:r>
+            <a:endParaRPr sz="1400" b="0">
+              <a:solidFill>
+                <a:srgbClr val="3C4947"/>
+              </a:solidFill>
+              <a:latin typeface="맑은 고딕"/>
+            </a:endParaRPr>
           </a:p>
           <a:p>
             <a:pPr algn="l">
@@ -14808,7 +15435,7 @@
 </file>
 
 <file path=ppt/slides/slide6.xml><?xml version="1.0" encoding="utf-8"?>
-<p:sld xmlns:a="http://schemas.openxmlformats.org/drawingml/2006/main" xmlns:p="http://schemas.openxmlformats.org/presentationml/2006/main" xmlns:r="http://schemas.openxmlformats.org/officeDocument/2006/relationships">
+<p:sld xmlns:a="http://schemas.openxmlformats.org/drawingml/2006/main" xmlns:r="http://schemas.openxmlformats.org/officeDocument/2006/relationships" xmlns:p="http://schemas.openxmlformats.org/presentationml/2006/main">
   <p:cSld>
     <p:bg>
       <p:bgPr>
@@ -14824,7 +15451,14 @@
         <p:cNvGrpSpPr/>
         <p:nvPr/>
       </p:nvGrpSpPr>
-      <p:grpSpPr/>
+      <p:grpSpPr>
+        <a:xfrm>
+          <a:off x="0" y="0"/>
+          <a:ext cx="0" cy="0"/>
+          <a:chOff x="0" y="0"/>
+          <a:chExt cx="0" cy="0"/>
+        </a:xfrm>
+      </p:grpSpPr>
       <p:sp>
         <p:nvSpPr>
           <p:cNvPr id="2" name="TextBox 1"/>
@@ -14983,6 +15617,7 @@
           <a:lstStyle/>
           <a:p>
             <a:pPr algn="ctr"/>
+            <a:endParaRPr/>
           </a:p>
         </p:txBody>
       </p:sp>
@@ -15031,6 +15666,7 @@
           <a:lstStyle/>
           <a:p>
             <a:pPr algn="ctr"/>
+            <a:endParaRPr/>
           </a:p>
         </p:txBody>
       </p:sp>
@@ -15198,6 +15834,7 @@
           <a:lstStyle/>
           <a:p>
             <a:pPr algn="ctr"/>
+            <a:endParaRPr/>
           </a:p>
         </p:txBody>
       </p:sp>
@@ -15365,6 +16002,7 @@
           <a:lstStyle/>
           <a:p>
             <a:pPr algn="ctr"/>
+            <a:endParaRPr/>
           </a:p>
         </p:txBody>
       </p:sp>
@@ -15535,7 +16173,7 @@
 </file>
 
 <file path=ppt/slides/slide7.xml><?xml version="1.0" encoding="utf-8"?>
-<p:sld xmlns:a="http://schemas.openxmlformats.org/drawingml/2006/main" xmlns:p="http://schemas.openxmlformats.org/presentationml/2006/main" xmlns:r="http://schemas.openxmlformats.org/officeDocument/2006/relationships">
+<p:sld xmlns:a="http://schemas.openxmlformats.org/drawingml/2006/main" xmlns:r="http://schemas.openxmlformats.org/officeDocument/2006/relationships" xmlns:p="http://schemas.openxmlformats.org/presentationml/2006/main">
   <p:cSld>
     <p:bg>
       <p:bgPr>
@@ -15551,7 +16189,14 @@
         <p:cNvGrpSpPr/>
         <p:nvPr/>
       </p:nvGrpSpPr>
-      <p:grpSpPr/>
+      <p:grpSpPr>
+        <a:xfrm>
+          <a:off x="0" y="0"/>
+          <a:ext cx="0" cy="0"/>
+          <a:chOff x="0" y="0"/>
+          <a:chExt cx="0" cy="0"/>
+        </a:xfrm>
+      </p:grpSpPr>
       <p:sp>
         <p:nvSpPr>
           <p:cNvPr id="2" name="TextBox 1"/>
@@ -15710,6 +16355,7 @@
           <a:lstStyle/>
           <a:p>
             <a:pPr algn="ctr"/>
+            <a:endParaRPr/>
           </a:p>
         </p:txBody>
       </p:sp>
@@ -15732,9 +16378,27 @@
                 <a:tableStyleId>{5C22544A-7EE6-4342-B048-85BDC9FD1C3A}</a:tableStyleId>
               </a:tblPr>
               <a:tblGrid>
-                <a:gridCol w="5615126"/>
-                <a:gridCol w="1633491"/>
-                <a:gridCol w="3266982"/>
+                <a:gridCol w="5615126">
+                  <a:extLst>
+                    <a:ext uri="{9D8B030D-6E8A-4147-A177-3AD203B41FA5}">
+                      <a16:colId xmlns:a16="http://schemas.microsoft.com/office/drawing/2014/main" val="20000"/>
+                    </a:ext>
+                  </a:extLst>
+                </a:gridCol>
+                <a:gridCol w="1633491">
+                  <a:extLst>
+                    <a:ext uri="{9D8B030D-6E8A-4147-A177-3AD203B41FA5}">
+                      <a16:colId xmlns:a16="http://schemas.microsoft.com/office/drawing/2014/main" val="20001"/>
+                    </a:ext>
+                  </a:extLst>
+                </a:gridCol>
+                <a:gridCol w="3266982">
+                  <a:extLst>
+                    <a:ext uri="{9D8B030D-6E8A-4147-A177-3AD203B41FA5}">
+                      <a16:colId xmlns:a16="http://schemas.microsoft.com/office/drawing/2014/main" val="20002"/>
+                    </a:ext>
+                  </a:extLst>
+                </a:gridCol>
               </a:tblGrid>
               <a:tr h="274320">
                 <a:tc>
@@ -15806,6 +16470,11 @@
                     </a:solidFill>
                   </a:tcPr>
                 </a:tc>
+                <a:extLst>
+                  <a:ext uri="{0D108BD9-81ED-4DB2-BD59-A6C34878D82A}">
+                    <a16:rowId xmlns:a16="http://schemas.microsoft.com/office/drawing/2014/main" val="10000"/>
+                  </a:ext>
+                </a:extLst>
               </a:tr>
               <a:tr h="274320">
                 <a:tc>
@@ -15877,6 +16546,11 @@
                     </a:solidFill>
                   </a:tcPr>
                 </a:tc>
+                <a:extLst>
+                  <a:ext uri="{0D108BD9-81ED-4DB2-BD59-A6C34878D82A}">
+                    <a16:rowId xmlns:a16="http://schemas.microsoft.com/office/drawing/2014/main" val="10001"/>
+                  </a:ext>
+                </a:extLst>
               </a:tr>
               <a:tr h="274320">
                 <a:tc>
@@ -15948,6 +16622,11 @@
                     </a:solidFill>
                   </a:tcPr>
                 </a:tc>
+                <a:extLst>
+                  <a:ext uri="{0D108BD9-81ED-4DB2-BD59-A6C34878D82A}">
+                    <a16:rowId xmlns:a16="http://schemas.microsoft.com/office/drawing/2014/main" val="10002"/>
+                  </a:ext>
+                </a:extLst>
               </a:tr>
               <a:tr h="274320">
                 <a:tc>
@@ -16019,6 +16698,11 @@
                     </a:solidFill>
                   </a:tcPr>
                 </a:tc>
+                <a:extLst>
+                  <a:ext uri="{0D108BD9-81ED-4DB2-BD59-A6C34878D82A}">
+                    <a16:rowId xmlns:a16="http://schemas.microsoft.com/office/drawing/2014/main" val="10003"/>
+                  </a:ext>
+                </a:extLst>
               </a:tr>
               <a:tr h="274320">
                 <a:tc>
@@ -16090,6 +16774,11 @@
                     </a:solidFill>
                   </a:tcPr>
                 </a:tc>
+                <a:extLst>
+                  <a:ext uri="{0D108BD9-81ED-4DB2-BD59-A6C34878D82A}">
+                    <a16:rowId xmlns:a16="http://schemas.microsoft.com/office/drawing/2014/main" val="10004"/>
+                  </a:ext>
+                </a:extLst>
               </a:tr>
               <a:tr h="274320">
                 <a:tc>
@@ -16161,6 +16850,11 @@
                     </a:solidFill>
                   </a:tcPr>
                 </a:tc>
+                <a:extLst>
+                  <a:ext uri="{0D108BD9-81ED-4DB2-BD59-A6C34878D82A}">
+                    <a16:rowId xmlns:a16="http://schemas.microsoft.com/office/drawing/2014/main" val="10005"/>
+                  </a:ext>
+                </a:extLst>
               </a:tr>
               <a:tr h="274320">
                 <a:tc>
@@ -16232,6 +16926,11 @@
                     </a:solidFill>
                   </a:tcPr>
                 </a:tc>
+                <a:extLst>
+                  <a:ext uri="{0D108BD9-81ED-4DB2-BD59-A6C34878D82A}">
+                    <a16:rowId xmlns:a16="http://schemas.microsoft.com/office/drawing/2014/main" val="10006"/>
+                  </a:ext>
+                </a:extLst>
               </a:tr>
             </a:tbl>
           </a:graphicData>
@@ -16282,6 +16981,7 @@
           <a:lstStyle/>
           <a:p>
             <a:pPr algn="ctr"/>
+            <a:endParaRPr/>
           </a:p>
         </p:txBody>
       </p:sp>
@@ -16365,7 +17065,7 @@
 </file>
 
 <file path=ppt/slides/slide8.xml><?xml version="1.0" encoding="utf-8"?>
-<p:sld xmlns:a="http://schemas.openxmlformats.org/drawingml/2006/main" xmlns:p="http://schemas.openxmlformats.org/presentationml/2006/main" xmlns:r="http://schemas.openxmlformats.org/officeDocument/2006/relationships">
+<p:sld xmlns:a="http://schemas.openxmlformats.org/drawingml/2006/main" xmlns:r="http://schemas.openxmlformats.org/officeDocument/2006/relationships" xmlns:p="http://schemas.openxmlformats.org/presentationml/2006/main">
   <p:cSld>
     <p:bg>
       <p:bgPr>
@@ -16381,7 +17081,14 @@
         <p:cNvGrpSpPr/>
         <p:nvPr/>
       </p:nvGrpSpPr>
-      <p:grpSpPr/>
+      <p:grpSpPr>
+        <a:xfrm>
+          <a:off x="0" y="0"/>
+          <a:ext cx="0" cy="0"/>
+          <a:chOff x="0" y="0"/>
+          <a:chExt cx="0" cy="0"/>
+        </a:xfrm>
+      </p:grpSpPr>
       <p:sp>
         <p:nvSpPr>
           <p:cNvPr id="2" name="TextBox 1"/>
@@ -16540,6 +17247,7 @@
           <a:lstStyle/>
           <a:p>
             <a:pPr algn="ctr"/>
+            <a:endParaRPr/>
           </a:p>
         </p:txBody>
       </p:sp>
@@ -16627,6 +17335,7 @@
           <a:lstStyle/>
           <a:p>
             <a:pPr algn="ctr"/>
+            <a:endParaRPr/>
           </a:p>
         </p:txBody>
       </p:sp>
@@ -16688,10 +17397,34 @@
                 <a:tableStyleId>{5C22544A-7EE6-4342-B048-85BDC9FD1C3A}</a:tableStyleId>
               </a:tblPr>
               <a:tblGrid>
-                <a:gridCol w="3310466"/>
-                <a:gridCol w="2336800"/>
-                <a:gridCol w="2531533"/>
-                <a:gridCol w="2336800"/>
+                <a:gridCol w="3310466">
+                  <a:extLst>
+                    <a:ext uri="{9D8B030D-6E8A-4147-A177-3AD203B41FA5}">
+                      <a16:colId xmlns:a16="http://schemas.microsoft.com/office/drawing/2014/main" val="20000"/>
+                    </a:ext>
+                  </a:extLst>
+                </a:gridCol>
+                <a:gridCol w="2336800">
+                  <a:extLst>
+                    <a:ext uri="{9D8B030D-6E8A-4147-A177-3AD203B41FA5}">
+                      <a16:colId xmlns:a16="http://schemas.microsoft.com/office/drawing/2014/main" val="20001"/>
+                    </a:ext>
+                  </a:extLst>
+                </a:gridCol>
+                <a:gridCol w="2531533">
+                  <a:extLst>
+                    <a:ext uri="{9D8B030D-6E8A-4147-A177-3AD203B41FA5}">
+                      <a16:colId xmlns:a16="http://schemas.microsoft.com/office/drawing/2014/main" val="20002"/>
+                    </a:ext>
+                  </a:extLst>
+                </a:gridCol>
+                <a:gridCol w="2336800">
+                  <a:extLst>
+                    <a:ext uri="{9D8B030D-6E8A-4147-A177-3AD203B41FA5}">
+                      <a16:colId xmlns:a16="http://schemas.microsoft.com/office/drawing/2014/main" val="20003"/>
+                    </a:ext>
+                  </a:extLst>
+                </a:gridCol>
               </a:tblGrid>
               <a:tr h="274320">
                 <a:tc>
@@ -16786,6 +17519,11 @@
                     </a:solidFill>
                   </a:tcPr>
                 </a:tc>
+                <a:extLst>
+                  <a:ext uri="{0D108BD9-81ED-4DB2-BD59-A6C34878D82A}">
+                    <a16:rowId xmlns:a16="http://schemas.microsoft.com/office/drawing/2014/main" val="10000"/>
+                  </a:ext>
+                </a:extLst>
               </a:tr>
               <a:tr h="274320">
                 <a:tc>
@@ -16880,6 +17618,11 @@
                     </a:solidFill>
                   </a:tcPr>
                 </a:tc>
+                <a:extLst>
+                  <a:ext uri="{0D108BD9-81ED-4DB2-BD59-A6C34878D82A}">
+                    <a16:rowId xmlns:a16="http://schemas.microsoft.com/office/drawing/2014/main" val="10001"/>
+                  </a:ext>
+                </a:extLst>
               </a:tr>
               <a:tr h="274320">
                 <a:tc>
@@ -16974,6 +17717,11 @@
                     </a:solidFill>
                   </a:tcPr>
                 </a:tc>
+                <a:extLst>
+                  <a:ext uri="{0D108BD9-81ED-4DB2-BD59-A6C34878D82A}">
+                    <a16:rowId xmlns:a16="http://schemas.microsoft.com/office/drawing/2014/main" val="10002"/>
+                  </a:ext>
+                </a:extLst>
               </a:tr>
               <a:tr h="274320">
                 <a:tc>
@@ -17068,6 +17816,11 @@
                     </a:solidFill>
                   </a:tcPr>
                 </a:tc>
+                <a:extLst>
+                  <a:ext uri="{0D108BD9-81ED-4DB2-BD59-A6C34878D82A}">
+                    <a16:rowId xmlns:a16="http://schemas.microsoft.com/office/drawing/2014/main" val="10003"/>
+                  </a:ext>
+                </a:extLst>
               </a:tr>
             </a:tbl>
           </a:graphicData>
@@ -17118,6 +17871,7 @@
           <a:lstStyle/>
           <a:p>
             <a:pPr algn="ctr"/>
+            <a:endParaRPr/>
           </a:p>
         </p:txBody>
       </p:sp>
@@ -17201,7 +17955,7 @@
 </file>
 
 <file path=ppt/slides/slide9.xml><?xml version="1.0" encoding="utf-8"?>
-<p:sld xmlns:a="http://schemas.openxmlformats.org/drawingml/2006/main" xmlns:p="http://schemas.openxmlformats.org/presentationml/2006/main" xmlns:r="http://schemas.openxmlformats.org/officeDocument/2006/relationships">
+<p:sld xmlns:a="http://schemas.openxmlformats.org/drawingml/2006/main" xmlns:r="http://schemas.openxmlformats.org/officeDocument/2006/relationships" xmlns:p="http://schemas.openxmlformats.org/presentationml/2006/main">
   <p:cSld>
     <p:bg>
       <p:bgPr>
@@ -17217,7 +17971,14 @@
         <p:cNvGrpSpPr/>
         <p:nvPr/>
       </p:nvGrpSpPr>
-      <p:grpSpPr/>
+      <p:grpSpPr>
+        <a:xfrm>
+          <a:off x="0" y="0"/>
+          <a:ext cx="0" cy="0"/>
+          <a:chOff x="0" y="0"/>
+          <a:chExt cx="0" cy="0"/>
+        </a:xfrm>
+      </p:grpSpPr>
       <p:sp>
         <p:nvSpPr>
           <p:cNvPr id="2" name="TextBox 1"/>
@@ -17376,6 +18137,7 @@
           <a:lstStyle/>
           <a:p>
             <a:pPr algn="ctr"/>
+            <a:endParaRPr/>
           </a:p>
         </p:txBody>
       </p:sp>
@@ -17460,7 +18222,7 @@
         </p:nvGraphicFramePr>
         <p:xfrm>
           <a:off x="822960" y="2743200"/>
-          <a:ext cx="5852160" cy="1371600"/>
+          <a:ext cx="5852160" cy="1426464"/>
         </p:xfrm>
         <a:graphic>
           <a:graphicData uri="http://schemas.openxmlformats.org/drawingml/2006/table">
@@ -17469,8 +18231,20 @@
                 <a:tableStyleId>{5C22544A-7EE6-4342-B048-85BDC9FD1C3A}</a:tableStyleId>
               </a:tblPr>
               <a:tblGrid>
-                <a:gridCol w="2926080"/>
-                <a:gridCol w="2926080"/>
+                <a:gridCol w="2926080">
+                  <a:extLst>
+                    <a:ext uri="{9D8B030D-6E8A-4147-A177-3AD203B41FA5}">
+                      <a16:colId xmlns:a16="http://schemas.microsoft.com/office/drawing/2014/main" val="20000"/>
+                    </a:ext>
+                  </a:extLst>
+                </a:gridCol>
+                <a:gridCol w="2926080">
+                  <a:extLst>
+                    <a:ext uri="{9D8B030D-6E8A-4147-A177-3AD203B41FA5}">
+                      <a16:colId xmlns:a16="http://schemas.microsoft.com/office/drawing/2014/main" val="20001"/>
+                    </a:ext>
+                  </a:extLst>
+                </a:gridCol>
               </a:tblGrid>
               <a:tr h="274320">
                 <a:tc>
@@ -17479,6 +18253,7 @@
                     <a:lstStyle/>
                     <a:p>
                       <a:pPr algn="l"/>
+                      <a:endParaRPr/>
                     </a:p>
                   </a:txBody>
                   <a:tcPr marL="82296" marR="82296" marT="27432" marB="27432" anchor="ctr">
@@ -17510,6 +18285,11 @@
                     </a:solidFill>
                   </a:tcPr>
                 </a:tc>
+                <a:extLst>
+                  <a:ext uri="{0D108BD9-81ED-4DB2-BD59-A6C34878D82A}">
+                    <a16:rowId xmlns:a16="http://schemas.microsoft.com/office/drawing/2014/main" val="10000"/>
+                  </a:ext>
+                </a:extLst>
               </a:tr>
               <a:tr h="274320">
                 <a:tc>
@@ -17558,6 +18338,11 @@
                     </a:solidFill>
                   </a:tcPr>
                 </a:tc>
+                <a:extLst>
+                  <a:ext uri="{0D108BD9-81ED-4DB2-BD59-A6C34878D82A}">
+                    <a16:rowId xmlns:a16="http://schemas.microsoft.com/office/drawing/2014/main" val="10001"/>
+                  </a:ext>
+                </a:extLst>
               </a:tr>
               <a:tr h="274320">
                 <a:tc>
@@ -17606,6 +18391,11 @@
                     </a:solidFill>
                   </a:tcPr>
                 </a:tc>
+                <a:extLst>
+                  <a:ext uri="{0D108BD9-81ED-4DB2-BD59-A6C34878D82A}">
+                    <a16:rowId xmlns:a16="http://schemas.microsoft.com/office/drawing/2014/main" val="10002"/>
+                  </a:ext>
+                </a:extLst>
               </a:tr>
               <a:tr h="274320">
                 <a:tc>
@@ -17654,6 +18444,11 @@
                     </a:solidFill>
                   </a:tcPr>
                 </a:tc>
+                <a:extLst>
+                  <a:ext uri="{0D108BD9-81ED-4DB2-BD59-A6C34878D82A}">
+                    <a16:rowId xmlns:a16="http://schemas.microsoft.com/office/drawing/2014/main" val="10003"/>
+                  </a:ext>
+                </a:extLst>
               </a:tr>
               <a:tr h="274320">
                 <a:tc>
@@ -17702,6 +18497,11 @@
                     </a:solidFill>
                   </a:tcPr>
                 </a:tc>
+                <a:extLst>
+                  <a:ext uri="{0D108BD9-81ED-4DB2-BD59-A6C34878D82A}">
+                    <a16:rowId xmlns:a16="http://schemas.microsoft.com/office/drawing/2014/main" val="10004"/>
+                  </a:ext>
+                </a:extLst>
               </a:tr>
             </a:tbl>
           </a:graphicData>
@@ -17752,6 +18552,7 @@
           <a:lstStyle/>
           <a:p>
             <a:pPr algn="ctr"/>
+            <a:endParaRPr/>
           </a:p>
         </p:txBody>
       </p:sp>
@@ -17814,15 +18615,12 @@
                 <a:spcPct val="125000"/>
               </a:lnSpc>
             </a:pPr>
-            <a:r>
-              <a:rPr sz="1300" b="0">
-                <a:solidFill>
-                  <a:srgbClr val="3C4947"/>
-                </a:solidFill>
-                <a:latin typeface="맑은 고딕"/>
-              </a:rPr>
-              <a:t/>
-            </a:r>
+            <a:endParaRPr sz="1300" b="1">
+              <a:solidFill>
+                <a:srgbClr val="131A19"/>
+              </a:solidFill>
+              <a:latin typeface="맑은 고딕"/>
+            </a:endParaRPr>
           </a:p>
           <a:p>
             <a:pPr algn="l">
@@ -17887,6 +18685,7 @@
           <a:lstStyle/>
           <a:p>
             <a:pPr algn="ctr"/>
+            <a:endParaRPr/>
           </a:p>
         </p:txBody>
       </p:sp>

</xml_diff>